<commit_message>
added viet-eng notebook, updated beam search logic, added decoding trace
</commit_message>
<xml_diff>
--- a/00_docs/DevLog.pptx
+++ b/00_docs/DevLog.pptx
@@ -3,25 +3,25 @@
 <p:presentation xmlns:a="http://schemas.openxmlformats.org/drawingml/2006/main" xmlns:r="http://schemas.openxmlformats.org/officeDocument/2006/relationships" xmlns:p="http://schemas.openxmlformats.org/presentationml/2006/main">
   <p:sldMasterIdLst>
     <p:sldMasterId id="2147483648" r:id="rId1"/>
-    <p:sldMasterId id="2147483660" r:id="rId3"/>
+    <p:sldMasterId id="2147483660" r:id="rId2"/>
   </p:sldMasterIdLst>
   <p:notesMasterIdLst>
-    <p:notesMasterId r:id="rId8"/>
+    <p:notesMasterId r:id="rId16"/>
   </p:notesMasterIdLst>
   <p:sldIdLst>
-    <p:sldId id="259" r:id="rId4"/>
-    <p:sldId id="265" r:id="rId5"/>
-    <p:sldId id="260" r:id="rId6"/>
-    <p:sldId id="262" r:id="rId7"/>
-    <p:sldId id="263" r:id="rId9"/>
-    <p:sldId id="264" r:id="rId10"/>
-    <p:sldId id="261" r:id="rId11"/>
-    <p:sldId id="257" r:id="rId12"/>
-    <p:sldId id="258" r:id="rId13"/>
-    <p:sldId id="256" r:id="rId14"/>
-    <p:sldId id="268" r:id="rId15"/>
-    <p:sldId id="272" r:id="rId16"/>
-    <p:sldId id="270" r:id="rId17"/>
+    <p:sldId id="259" r:id="rId3"/>
+    <p:sldId id="265" r:id="rId4"/>
+    <p:sldId id="260" r:id="rId5"/>
+    <p:sldId id="262" r:id="rId6"/>
+    <p:sldId id="263" r:id="rId7"/>
+    <p:sldId id="264" r:id="rId8"/>
+    <p:sldId id="261" r:id="rId9"/>
+    <p:sldId id="257" r:id="rId10"/>
+    <p:sldId id="258" r:id="rId11"/>
+    <p:sldId id="256" r:id="rId12"/>
+    <p:sldId id="268" r:id="rId13"/>
+    <p:sldId id="272" r:id="rId14"/>
+    <p:sldId id="270" r:id="rId15"/>
   </p:sldIdLst>
   <p:sldSz cx="12192000" cy="6858000"/>
   <p:notesSz cx="6858000" cy="9144000"/>
@@ -221,6 +221,7 @@
           <a:p>
             <a:fld id="{16959575-F8F4-4BF3-9B57-12013E1BF857}" type="datetimeFigureOut">
               <a:rPr kumimoji="1" lang="ja-JP" altLang="en-US" smtClean="0"/>
+              <a:t>2026/8/30</a:t>
             </a:fld>
             <a:endParaRPr kumimoji="1" lang="ja-JP" altLang="en-US"/>
           </a:p>
@@ -287,7 +288,6 @@
               <a:rPr kumimoji="1" lang="en-US" altLang="ja-JP"/>
               <a:t>Click to edit Master text styles</a:t>
             </a:r>
-            <a:endParaRPr kumimoji="1" lang="en-US" altLang="ja-JP"/>
           </a:p>
           <a:p>
             <a:pPr lvl="1"/>
@@ -295,7 +295,6 @@
               <a:rPr kumimoji="1" lang="en-US" altLang="ja-JP"/>
               <a:t>Second level</a:t>
             </a:r>
-            <a:endParaRPr kumimoji="1" lang="en-US" altLang="ja-JP"/>
           </a:p>
           <a:p>
             <a:pPr lvl="2"/>
@@ -303,7 +302,6 @@
               <a:rPr kumimoji="1" lang="en-US" altLang="ja-JP"/>
               <a:t>Third level</a:t>
             </a:r>
-            <a:endParaRPr kumimoji="1" lang="en-US" altLang="ja-JP"/>
           </a:p>
           <a:p>
             <a:pPr lvl="3"/>
@@ -311,7 +309,6 @@
               <a:rPr kumimoji="1" lang="en-US" altLang="ja-JP"/>
               <a:t>Fourth level</a:t>
             </a:r>
-            <a:endParaRPr kumimoji="1" lang="en-US" altLang="ja-JP"/>
           </a:p>
           <a:p>
             <a:pPr lvl="4"/>
@@ -383,6 +380,7 @@
           <a:p>
             <a:fld id="{FE25129E-3C77-4430-9B22-F2D6B19928E8}" type="slidenum">
               <a:rPr kumimoji="1" lang="ja-JP" altLang="en-US" smtClean="0"/>
+              <a:t>‹#›</a:t>
             </a:fld>
             <a:endParaRPr kumimoji="1" lang="ja-JP" altLang="en-US"/>
           </a:p>
@@ -551,6 +549,7 @@
           <a:p>
             <a:fld id="{FE25129E-3C77-4430-9B22-F2D6B19928E8}" type="slidenum">
               <a:rPr kumimoji="1" lang="ja-JP" altLang="en-US" smtClean="0"/>
+              <a:t>4</a:t>
             </a:fld>
             <a:endParaRPr kumimoji="1" lang="ja-JP" altLang="en-US"/>
           </a:p>
@@ -629,6 +628,7 @@
           <a:p>
             <a:fld id="{FE25129E-3C77-4430-9B22-F2D6B19928E8}" type="slidenum">
               <a:rPr kumimoji="1" lang="ja-JP" altLang="en-US" smtClean="0"/>
+              <a:t>5</a:t>
             </a:fld>
             <a:endParaRPr kumimoji="1" lang="ja-JP" altLang="en-US"/>
           </a:p>
@@ -707,6 +707,7 @@
           <a:p>
             <a:fld id="{FE25129E-3C77-4430-9B22-F2D6B19928E8}" type="slidenum">
               <a:rPr kumimoji="1" lang="ja-JP" altLang="en-US" smtClean="0"/>
+              <a:t>6</a:t>
             </a:fld>
             <a:endParaRPr kumimoji="1" lang="ja-JP" altLang="en-US"/>
           </a:p>
@@ -851,6 +852,7 @@
           <a:p>
             <a:fld id="{AE545288-4E63-4A9A-9FF7-11823647D6C9}" type="datetimeFigureOut">
               <a:rPr kumimoji="1" lang="ja-JP" altLang="en-US" smtClean="0"/>
+              <a:t>2026/8/30</a:t>
             </a:fld>
             <a:endParaRPr kumimoji="1" lang="ja-JP" altLang="en-US"/>
           </a:p>
@@ -892,6 +894,7 @@
           <a:p>
             <a:fld id="{19167D3B-9FB3-4BD5-BAC9-DA5EEE515399}" type="slidenum">
               <a:rPr kumimoji="1" lang="ja-JP" altLang="en-US" smtClean="0"/>
+              <a:t>‹#›</a:t>
             </a:fld>
             <a:endParaRPr kumimoji="1" lang="ja-JP" altLang="en-US"/>
           </a:p>
@@ -965,7 +968,6 @@
               <a:rPr kumimoji="1" lang="en-US" altLang="ja-JP"/>
               <a:t>Click to edit Master text styles</a:t>
             </a:r>
-            <a:endParaRPr kumimoji="1" lang="en-US" altLang="ja-JP"/>
           </a:p>
           <a:p>
             <a:pPr lvl="1"/>
@@ -973,7 +975,6 @@
               <a:rPr kumimoji="1" lang="en-US" altLang="ja-JP"/>
               <a:t>Second level</a:t>
             </a:r>
-            <a:endParaRPr kumimoji="1" lang="en-US" altLang="ja-JP"/>
           </a:p>
           <a:p>
             <a:pPr lvl="2"/>
@@ -981,7 +982,6 @@
               <a:rPr kumimoji="1" lang="en-US" altLang="ja-JP"/>
               <a:t>Third level</a:t>
             </a:r>
-            <a:endParaRPr kumimoji="1" lang="en-US" altLang="ja-JP"/>
           </a:p>
           <a:p>
             <a:pPr lvl="3"/>
@@ -989,7 +989,6 @@
               <a:rPr kumimoji="1" lang="en-US" altLang="ja-JP"/>
               <a:t>Fourth level</a:t>
             </a:r>
-            <a:endParaRPr kumimoji="1" lang="en-US" altLang="ja-JP"/>
           </a:p>
           <a:p>
             <a:pPr lvl="4"/>
@@ -1018,6 +1017,7 @@
           <a:p>
             <a:fld id="{AE545288-4E63-4A9A-9FF7-11823647D6C9}" type="datetimeFigureOut">
               <a:rPr kumimoji="1" lang="ja-JP" altLang="en-US" smtClean="0"/>
+              <a:t>2026/8/30</a:t>
             </a:fld>
             <a:endParaRPr kumimoji="1" lang="ja-JP" altLang="en-US"/>
           </a:p>
@@ -1059,6 +1059,7 @@
           <a:p>
             <a:fld id="{19167D3B-9FB3-4BD5-BAC9-DA5EEE515399}" type="slidenum">
               <a:rPr kumimoji="1" lang="ja-JP" altLang="en-US" smtClean="0"/>
+              <a:t>‹#›</a:t>
             </a:fld>
             <a:endParaRPr kumimoji="1" lang="ja-JP" altLang="en-US"/>
           </a:p>
@@ -1142,7 +1143,6 @@
               <a:rPr kumimoji="1" lang="en-US" altLang="ja-JP"/>
               <a:t>Click to edit Master text styles</a:t>
             </a:r>
-            <a:endParaRPr kumimoji="1" lang="en-US" altLang="ja-JP"/>
           </a:p>
           <a:p>
             <a:pPr lvl="1"/>
@@ -1150,7 +1150,6 @@
               <a:rPr kumimoji="1" lang="en-US" altLang="ja-JP"/>
               <a:t>Second level</a:t>
             </a:r>
-            <a:endParaRPr kumimoji="1" lang="en-US" altLang="ja-JP"/>
           </a:p>
           <a:p>
             <a:pPr lvl="2"/>
@@ -1158,7 +1157,6 @@
               <a:rPr kumimoji="1" lang="en-US" altLang="ja-JP"/>
               <a:t>Third level</a:t>
             </a:r>
-            <a:endParaRPr kumimoji="1" lang="en-US" altLang="ja-JP"/>
           </a:p>
           <a:p>
             <a:pPr lvl="3"/>
@@ -1166,7 +1164,6 @@
               <a:rPr kumimoji="1" lang="en-US" altLang="ja-JP"/>
               <a:t>Fourth level</a:t>
             </a:r>
-            <a:endParaRPr kumimoji="1" lang="en-US" altLang="ja-JP"/>
           </a:p>
           <a:p>
             <a:pPr lvl="4"/>
@@ -1195,6 +1192,7 @@
           <a:p>
             <a:fld id="{AE545288-4E63-4A9A-9FF7-11823647D6C9}" type="datetimeFigureOut">
               <a:rPr kumimoji="1" lang="ja-JP" altLang="en-US" smtClean="0"/>
+              <a:t>2026/8/30</a:t>
             </a:fld>
             <a:endParaRPr kumimoji="1" lang="ja-JP" altLang="en-US"/>
           </a:p>
@@ -1236,6 +1234,7 @@
           <a:p>
             <a:fld id="{19167D3B-9FB3-4BD5-BAC9-DA5EEE515399}" type="slidenum">
               <a:rPr kumimoji="1" lang="ja-JP" altLang="en-US" smtClean="0"/>
+              <a:t>‹#›</a:t>
             </a:fld>
             <a:endParaRPr kumimoji="1" lang="ja-JP" altLang="en-US"/>
           </a:p>
@@ -1380,6 +1379,7 @@
           <a:p>
             <a:fld id="{AE545288-4E63-4A9A-9FF7-11823647D6C9}" type="datetimeFigureOut">
               <a:rPr kumimoji="1" lang="ja-JP" altLang="en-US" smtClean="0"/>
+              <a:t>2026/8/30</a:t>
             </a:fld>
             <a:endParaRPr kumimoji="1" lang="ja-JP" altLang="en-US"/>
           </a:p>
@@ -1421,6 +1421,7 @@
           <a:p>
             <a:fld id="{19167D3B-9FB3-4BD5-BAC9-DA5EEE515399}" type="slidenum">
               <a:rPr kumimoji="1" lang="ja-JP" altLang="en-US" smtClean="0"/>
+              <a:t>‹#›</a:t>
             </a:fld>
             <a:endParaRPr kumimoji="1" lang="ja-JP" altLang="en-US"/>
           </a:p>
@@ -1494,7 +1495,6 @@
               <a:rPr kumimoji="1" lang="en-US" altLang="ja-JP"/>
               <a:t>Click to edit Master text styles</a:t>
             </a:r>
-            <a:endParaRPr kumimoji="1" lang="en-US" altLang="ja-JP"/>
           </a:p>
           <a:p>
             <a:pPr lvl="1"/>
@@ -1502,7 +1502,6 @@
               <a:rPr kumimoji="1" lang="en-US" altLang="ja-JP"/>
               <a:t>Second level</a:t>
             </a:r>
-            <a:endParaRPr kumimoji="1" lang="en-US" altLang="ja-JP"/>
           </a:p>
           <a:p>
             <a:pPr lvl="2"/>
@@ -1510,7 +1509,6 @@
               <a:rPr kumimoji="1" lang="en-US" altLang="ja-JP"/>
               <a:t>Third level</a:t>
             </a:r>
-            <a:endParaRPr kumimoji="1" lang="en-US" altLang="ja-JP"/>
           </a:p>
           <a:p>
             <a:pPr lvl="3"/>
@@ -1518,7 +1516,6 @@
               <a:rPr kumimoji="1" lang="en-US" altLang="ja-JP"/>
               <a:t>Fourth level</a:t>
             </a:r>
-            <a:endParaRPr kumimoji="1" lang="en-US" altLang="ja-JP"/>
           </a:p>
           <a:p>
             <a:pPr lvl="4"/>
@@ -1547,6 +1544,7 @@
           <a:p>
             <a:fld id="{AE545288-4E63-4A9A-9FF7-11823647D6C9}" type="datetimeFigureOut">
               <a:rPr kumimoji="1" lang="ja-JP" altLang="en-US" smtClean="0"/>
+              <a:t>2026/8/30</a:t>
             </a:fld>
             <a:endParaRPr kumimoji="1" lang="ja-JP" altLang="en-US"/>
           </a:p>
@@ -1588,6 +1586,7 @@
           <a:p>
             <a:fld id="{19167D3B-9FB3-4BD5-BAC9-DA5EEE515399}" type="slidenum">
               <a:rPr kumimoji="1" lang="ja-JP" altLang="en-US" smtClean="0"/>
+              <a:t>‹#›</a:t>
             </a:fld>
             <a:endParaRPr kumimoji="1" lang="ja-JP" altLang="en-US"/>
           </a:p>
@@ -1766,7 +1765,6 @@
               <a:rPr kumimoji="1" lang="en-US" altLang="ja-JP"/>
               <a:t>Click to edit Master text styles</a:t>
             </a:r>
-            <a:endParaRPr kumimoji="1" lang="en-US" altLang="ja-JP"/>
           </a:p>
         </p:txBody>
       </p:sp>
@@ -1787,6 +1785,7 @@
           <a:p>
             <a:fld id="{AE545288-4E63-4A9A-9FF7-11823647D6C9}" type="datetimeFigureOut">
               <a:rPr kumimoji="1" lang="ja-JP" altLang="en-US" smtClean="0"/>
+              <a:t>2026/8/30</a:t>
             </a:fld>
             <a:endParaRPr kumimoji="1" lang="ja-JP" altLang="en-US"/>
           </a:p>
@@ -1828,6 +1827,7 @@
           <a:p>
             <a:fld id="{19167D3B-9FB3-4BD5-BAC9-DA5EEE515399}" type="slidenum">
               <a:rPr kumimoji="1" lang="ja-JP" altLang="en-US" smtClean="0"/>
+              <a:t>‹#›</a:t>
             </a:fld>
             <a:endParaRPr kumimoji="1" lang="ja-JP" altLang="en-US"/>
           </a:p>
@@ -1906,7 +1906,6 @@
               <a:rPr kumimoji="1" lang="en-US" altLang="ja-JP"/>
               <a:t>Click to edit Master text styles</a:t>
             </a:r>
-            <a:endParaRPr kumimoji="1" lang="en-US" altLang="ja-JP"/>
           </a:p>
           <a:p>
             <a:pPr lvl="1"/>
@@ -1914,7 +1913,6 @@
               <a:rPr kumimoji="1" lang="en-US" altLang="ja-JP"/>
               <a:t>Second level</a:t>
             </a:r>
-            <a:endParaRPr kumimoji="1" lang="en-US" altLang="ja-JP"/>
           </a:p>
           <a:p>
             <a:pPr lvl="2"/>
@@ -1922,7 +1920,6 @@
               <a:rPr kumimoji="1" lang="en-US" altLang="ja-JP"/>
               <a:t>Third level</a:t>
             </a:r>
-            <a:endParaRPr kumimoji="1" lang="en-US" altLang="ja-JP"/>
           </a:p>
           <a:p>
             <a:pPr lvl="3"/>
@@ -1930,7 +1927,6 @@
               <a:rPr kumimoji="1" lang="en-US" altLang="ja-JP"/>
               <a:t>Fourth level</a:t>
             </a:r>
-            <a:endParaRPr kumimoji="1" lang="en-US" altLang="ja-JP"/>
           </a:p>
           <a:p>
             <a:pPr lvl="4"/>
@@ -1967,7 +1963,6 @@
               <a:rPr kumimoji="1" lang="en-US" altLang="ja-JP"/>
               <a:t>Click to edit Master text styles</a:t>
             </a:r>
-            <a:endParaRPr kumimoji="1" lang="en-US" altLang="ja-JP"/>
           </a:p>
           <a:p>
             <a:pPr lvl="1"/>
@@ -1975,7 +1970,6 @@
               <a:rPr kumimoji="1" lang="en-US" altLang="ja-JP"/>
               <a:t>Second level</a:t>
             </a:r>
-            <a:endParaRPr kumimoji="1" lang="en-US" altLang="ja-JP"/>
           </a:p>
           <a:p>
             <a:pPr lvl="2"/>
@@ -1983,7 +1977,6 @@
               <a:rPr kumimoji="1" lang="en-US" altLang="ja-JP"/>
               <a:t>Third level</a:t>
             </a:r>
-            <a:endParaRPr kumimoji="1" lang="en-US" altLang="ja-JP"/>
           </a:p>
           <a:p>
             <a:pPr lvl="3"/>
@@ -1991,7 +1984,6 @@
               <a:rPr kumimoji="1" lang="en-US" altLang="ja-JP"/>
               <a:t>Fourth level</a:t>
             </a:r>
-            <a:endParaRPr kumimoji="1" lang="en-US" altLang="ja-JP"/>
           </a:p>
           <a:p>
             <a:pPr lvl="4"/>
@@ -2020,6 +2012,7 @@
           <a:p>
             <a:fld id="{AE545288-4E63-4A9A-9FF7-11823647D6C9}" type="datetimeFigureOut">
               <a:rPr kumimoji="1" lang="ja-JP" altLang="en-US" smtClean="0"/>
+              <a:t>2026/8/30</a:t>
             </a:fld>
             <a:endParaRPr kumimoji="1" lang="ja-JP" altLang="en-US"/>
           </a:p>
@@ -2061,6 +2054,7 @@
           <a:p>
             <a:fld id="{19167D3B-9FB3-4BD5-BAC9-DA5EEE515399}" type="slidenum">
               <a:rPr kumimoji="1" lang="ja-JP" altLang="en-US" smtClean="0"/>
+              <a:t>‹#›</a:t>
             </a:fld>
             <a:endParaRPr kumimoji="1" lang="ja-JP" altLang="en-US"/>
           </a:p>
@@ -2181,7 +2175,6 @@
               <a:rPr kumimoji="1" lang="en-US" altLang="ja-JP"/>
               <a:t>Click to edit Master text styles</a:t>
             </a:r>
-            <a:endParaRPr kumimoji="1" lang="en-US" altLang="ja-JP"/>
           </a:p>
         </p:txBody>
       </p:sp>
@@ -2210,7 +2203,6 @@
               <a:rPr kumimoji="1" lang="en-US" altLang="ja-JP"/>
               <a:t>Click to edit Master text styles</a:t>
             </a:r>
-            <a:endParaRPr kumimoji="1" lang="en-US" altLang="ja-JP"/>
           </a:p>
           <a:p>
             <a:pPr lvl="1"/>
@@ -2218,7 +2210,6 @@
               <a:rPr kumimoji="1" lang="en-US" altLang="ja-JP"/>
               <a:t>Second level</a:t>
             </a:r>
-            <a:endParaRPr kumimoji="1" lang="en-US" altLang="ja-JP"/>
           </a:p>
           <a:p>
             <a:pPr lvl="2"/>
@@ -2226,7 +2217,6 @@
               <a:rPr kumimoji="1" lang="en-US" altLang="ja-JP"/>
               <a:t>Third level</a:t>
             </a:r>
-            <a:endParaRPr kumimoji="1" lang="en-US" altLang="ja-JP"/>
           </a:p>
           <a:p>
             <a:pPr lvl="3"/>
@@ -2234,7 +2224,6 @@
               <a:rPr kumimoji="1" lang="en-US" altLang="ja-JP"/>
               <a:t>Fourth level</a:t>
             </a:r>
-            <a:endParaRPr kumimoji="1" lang="en-US" altLang="ja-JP"/>
           </a:p>
           <a:p>
             <a:pPr lvl="4"/>
@@ -2308,7 +2297,6 @@
               <a:rPr kumimoji="1" lang="en-US" altLang="ja-JP"/>
               <a:t>Click to edit Master text styles</a:t>
             </a:r>
-            <a:endParaRPr kumimoji="1" lang="en-US" altLang="ja-JP"/>
           </a:p>
         </p:txBody>
       </p:sp>
@@ -2337,7 +2325,6 @@
               <a:rPr kumimoji="1" lang="en-US" altLang="ja-JP"/>
               <a:t>Click to edit Master text styles</a:t>
             </a:r>
-            <a:endParaRPr kumimoji="1" lang="en-US" altLang="ja-JP"/>
           </a:p>
           <a:p>
             <a:pPr lvl="1"/>
@@ -2345,7 +2332,6 @@
               <a:rPr kumimoji="1" lang="en-US" altLang="ja-JP"/>
               <a:t>Second level</a:t>
             </a:r>
-            <a:endParaRPr kumimoji="1" lang="en-US" altLang="ja-JP"/>
           </a:p>
           <a:p>
             <a:pPr lvl="2"/>
@@ -2353,7 +2339,6 @@
               <a:rPr kumimoji="1" lang="en-US" altLang="ja-JP"/>
               <a:t>Third level</a:t>
             </a:r>
-            <a:endParaRPr kumimoji="1" lang="en-US" altLang="ja-JP"/>
           </a:p>
           <a:p>
             <a:pPr lvl="3"/>
@@ -2361,7 +2346,6 @@
               <a:rPr kumimoji="1" lang="en-US" altLang="ja-JP"/>
               <a:t>Fourth level</a:t>
             </a:r>
-            <a:endParaRPr kumimoji="1" lang="en-US" altLang="ja-JP"/>
           </a:p>
           <a:p>
             <a:pPr lvl="4"/>
@@ -2390,6 +2374,7 @@
           <a:p>
             <a:fld id="{AE545288-4E63-4A9A-9FF7-11823647D6C9}" type="datetimeFigureOut">
               <a:rPr kumimoji="1" lang="ja-JP" altLang="en-US" smtClean="0"/>
+              <a:t>2026/8/30</a:t>
             </a:fld>
             <a:endParaRPr kumimoji="1" lang="ja-JP" altLang="en-US"/>
           </a:p>
@@ -2431,6 +2416,7 @@
           <a:p>
             <a:fld id="{19167D3B-9FB3-4BD5-BAC9-DA5EEE515399}" type="slidenum">
               <a:rPr kumimoji="1" lang="ja-JP" altLang="en-US" smtClean="0"/>
+              <a:t>‹#›</a:t>
             </a:fld>
             <a:endParaRPr kumimoji="1" lang="ja-JP" altLang="en-US"/>
           </a:p>
@@ -2501,6 +2487,7 @@
           <a:p>
             <a:fld id="{AE545288-4E63-4A9A-9FF7-11823647D6C9}" type="datetimeFigureOut">
               <a:rPr kumimoji="1" lang="ja-JP" altLang="en-US" smtClean="0"/>
+              <a:t>2026/8/30</a:t>
             </a:fld>
             <a:endParaRPr kumimoji="1" lang="ja-JP" altLang="en-US"/>
           </a:p>
@@ -2542,6 +2529,7 @@
           <a:p>
             <a:fld id="{19167D3B-9FB3-4BD5-BAC9-DA5EEE515399}" type="slidenum">
               <a:rPr kumimoji="1" lang="ja-JP" altLang="en-US" smtClean="0"/>
+              <a:t>‹#›</a:t>
             </a:fld>
             <a:endParaRPr kumimoji="1" lang="ja-JP" altLang="en-US"/>
           </a:p>
@@ -2589,6 +2577,7 @@
           <a:p>
             <a:fld id="{AE545288-4E63-4A9A-9FF7-11823647D6C9}" type="datetimeFigureOut">
               <a:rPr kumimoji="1" lang="ja-JP" altLang="en-US" smtClean="0"/>
+              <a:t>2026/8/30</a:t>
             </a:fld>
             <a:endParaRPr kumimoji="1" lang="ja-JP" altLang="en-US"/>
           </a:p>
@@ -2630,6 +2619,7 @@
           <a:p>
             <a:fld id="{19167D3B-9FB3-4BD5-BAC9-DA5EEE515399}" type="slidenum">
               <a:rPr kumimoji="1" lang="ja-JP" altLang="en-US" smtClean="0"/>
+              <a:t>‹#›</a:t>
             </a:fld>
             <a:endParaRPr kumimoji="1" lang="ja-JP" altLang="en-US"/>
           </a:p>
@@ -2745,7 +2735,6 @@
               <a:rPr kumimoji="1" lang="en-US" altLang="ja-JP"/>
               <a:t>Click to edit Master text styles</a:t>
             </a:r>
-            <a:endParaRPr kumimoji="1" lang="en-US" altLang="ja-JP"/>
           </a:p>
           <a:p>
             <a:pPr lvl="1"/>
@@ -2753,7 +2742,6 @@
               <a:rPr kumimoji="1" lang="en-US" altLang="ja-JP"/>
               <a:t>Second level</a:t>
             </a:r>
-            <a:endParaRPr kumimoji="1" lang="en-US" altLang="ja-JP"/>
           </a:p>
           <a:p>
             <a:pPr lvl="2"/>
@@ -2761,7 +2749,6 @@
               <a:rPr kumimoji="1" lang="en-US" altLang="ja-JP"/>
               <a:t>Third level</a:t>
             </a:r>
-            <a:endParaRPr kumimoji="1" lang="en-US" altLang="ja-JP"/>
           </a:p>
           <a:p>
             <a:pPr lvl="3"/>
@@ -2769,7 +2756,6 @@
               <a:rPr kumimoji="1" lang="en-US" altLang="ja-JP"/>
               <a:t>Fourth level</a:t>
             </a:r>
-            <a:endParaRPr kumimoji="1" lang="en-US" altLang="ja-JP"/>
           </a:p>
           <a:p>
             <a:pPr lvl="4"/>
@@ -2843,7 +2829,6 @@
               <a:rPr kumimoji="1" lang="en-US" altLang="ja-JP"/>
               <a:t>Click to edit Master text styles</a:t>
             </a:r>
-            <a:endParaRPr kumimoji="1" lang="en-US" altLang="ja-JP"/>
           </a:p>
         </p:txBody>
       </p:sp>
@@ -2864,6 +2849,7 @@
           <a:p>
             <a:fld id="{AE545288-4E63-4A9A-9FF7-11823647D6C9}" type="datetimeFigureOut">
               <a:rPr kumimoji="1" lang="ja-JP" altLang="en-US" smtClean="0"/>
+              <a:t>2026/8/30</a:t>
             </a:fld>
             <a:endParaRPr kumimoji="1" lang="ja-JP" altLang="en-US"/>
           </a:p>
@@ -2905,6 +2891,7 @@
           <a:p>
             <a:fld id="{19167D3B-9FB3-4BD5-BAC9-DA5EEE515399}" type="slidenum">
               <a:rPr kumimoji="1" lang="ja-JP" altLang="en-US" smtClean="0"/>
+              <a:t>‹#›</a:t>
             </a:fld>
             <a:endParaRPr kumimoji="1" lang="ja-JP" altLang="en-US"/>
           </a:p>
@@ -2978,7 +2965,6 @@
               <a:rPr kumimoji="1" lang="en-US" altLang="ja-JP"/>
               <a:t>Click to edit Master text styles</a:t>
             </a:r>
-            <a:endParaRPr kumimoji="1" lang="en-US" altLang="ja-JP"/>
           </a:p>
           <a:p>
             <a:pPr lvl="1"/>
@@ -2986,7 +2972,6 @@
               <a:rPr kumimoji="1" lang="en-US" altLang="ja-JP"/>
               <a:t>Second level</a:t>
             </a:r>
-            <a:endParaRPr kumimoji="1" lang="en-US" altLang="ja-JP"/>
           </a:p>
           <a:p>
             <a:pPr lvl="2"/>
@@ -2994,7 +2979,6 @@
               <a:rPr kumimoji="1" lang="en-US" altLang="ja-JP"/>
               <a:t>Third level</a:t>
             </a:r>
-            <a:endParaRPr kumimoji="1" lang="en-US" altLang="ja-JP"/>
           </a:p>
           <a:p>
             <a:pPr lvl="3"/>
@@ -3002,7 +2986,6 @@
               <a:rPr kumimoji="1" lang="en-US" altLang="ja-JP"/>
               <a:t>Fourth level</a:t>
             </a:r>
-            <a:endParaRPr kumimoji="1" lang="en-US" altLang="ja-JP"/>
           </a:p>
           <a:p>
             <a:pPr lvl="4"/>
@@ -3031,6 +3014,7 @@
           <a:p>
             <a:fld id="{AE545288-4E63-4A9A-9FF7-11823647D6C9}" type="datetimeFigureOut">
               <a:rPr kumimoji="1" lang="ja-JP" altLang="en-US" smtClean="0"/>
+              <a:t>2026/8/30</a:t>
             </a:fld>
             <a:endParaRPr kumimoji="1" lang="ja-JP" altLang="en-US"/>
           </a:p>
@@ -3072,6 +3056,7 @@
           <a:p>
             <a:fld id="{19167D3B-9FB3-4BD5-BAC9-DA5EEE515399}" type="slidenum">
               <a:rPr kumimoji="1" lang="ja-JP" altLang="en-US" smtClean="0"/>
+              <a:t>‹#›</a:t>
             </a:fld>
             <a:endParaRPr kumimoji="1" lang="ja-JP" altLang="en-US"/>
           </a:p>
@@ -3257,7 +3242,6 @@
               <a:rPr kumimoji="1" lang="en-US" altLang="ja-JP"/>
               <a:t>Click to edit Master text styles</a:t>
             </a:r>
-            <a:endParaRPr kumimoji="1" lang="en-US" altLang="ja-JP"/>
           </a:p>
         </p:txBody>
       </p:sp>
@@ -3278,6 +3262,7 @@
           <a:p>
             <a:fld id="{AE545288-4E63-4A9A-9FF7-11823647D6C9}" type="datetimeFigureOut">
               <a:rPr kumimoji="1" lang="ja-JP" altLang="en-US" smtClean="0"/>
+              <a:t>2026/8/30</a:t>
             </a:fld>
             <a:endParaRPr kumimoji="1" lang="ja-JP" altLang="en-US"/>
           </a:p>
@@ -3319,6 +3304,7 @@
           <a:p>
             <a:fld id="{19167D3B-9FB3-4BD5-BAC9-DA5EEE515399}" type="slidenum">
               <a:rPr kumimoji="1" lang="ja-JP" altLang="en-US" smtClean="0"/>
+              <a:t>‹#›</a:t>
             </a:fld>
             <a:endParaRPr kumimoji="1" lang="ja-JP" altLang="en-US"/>
           </a:p>
@@ -3392,7 +3378,6 @@
               <a:rPr kumimoji="1" lang="en-US" altLang="ja-JP"/>
               <a:t>Click to edit Master text styles</a:t>
             </a:r>
-            <a:endParaRPr kumimoji="1" lang="en-US" altLang="ja-JP"/>
           </a:p>
           <a:p>
             <a:pPr lvl="1"/>
@@ -3400,7 +3385,6 @@
               <a:rPr kumimoji="1" lang="en-US" altLang="ja-JP"/>
               <a:t>Second level</a:t>
             </a:r>
-            <a:endParaRPr kumimoji="1" lang="en-US" altLang="ja-JP"/>
           </a:p>
           <a:p>
             <a:pPr lvl="2"/>
@@ -3408,7 +3392,6 @@
               <a:rPr kumimoji="1" lang="en-US" altLang="ja-JP"/>
               <a:t>Third level</a:t>
             </a:r>
-            <a:endParaRPr kumimoji="1" lang="en-US" altLang="ja-JP"/>
           </a:p>
           <a:p>
             <a:pPr lvl="3"/>
@@ -3416,7 +3399,6 @@
               <a:rPr kumimoji="1" lang="en-US" altLang="ja-JP"/>
               <a:t>Fourth level</a:t>
             </a:r>
-            <a:endParaRPr kumimoji="1" lang="en-US" altLang="ja-JP"/>
           </a:p>
           <a:p>
             <a:pPr lvl="4"/>
@@ -3445,6 +3427,7 @@
           <a:p>
             <a:fld id="{AE545288-4E63-4A9A-9FF7-11823647D6C9}" type="datetimeFigureOut">
               <a:rPr kumimoji="1" lang="ja-JP" altLang="en-US" smtClean="0"/>
+              <a:t>2026/8/30</a:t>
             </a:fld>
             <a:endParaRPr kumimoji="1" lang="ja-JP" altLang="en-US"/>
           </a:p>
@@ -3486,6 +3469,7 @@
           <a:p>
             <a:fld id="{19167D3B-9FB3-4BD5-BAC9-DA5EEE515399}" type="slidenum">
               <a:rPr kumimoji="1" lang="ja-JP" altLang="en-US" smtClean="0"/>
+              <a:t>‹#›</a:t>
             </a:fld>
             <a:endParaRPr kumimoji="1" lang="ja-JP" altLang="en-US"/>
           </a:p>
@@ -3569,7 +3553,6 @@
               <a:rPr kumimoji="1" lang="en-US" altLang="ja-JP"/>
               <a:t>Click to edit Master text styles</a:t>
             </a:r>
-            <a:endParaRPr kumimoji="1" lang="en-US" altLang="ja-JP"/>
           </a:p>
           <a:p>
             <a:pPr lvl="1"/>
@@ -3577,7 +3560,6 @@
               <a:rPr kumimoji="1" lang="en-US" altLang="ja-JP"/>
               <a:t>Second level</a:t>
             </a:r>
-            <a:endParaRPr kumimoji="1" lang="en-US" altLang="ja-JP"/>
           </a:p>
           <a:p>
             <a:pPr lvl="2"/>
@@ -3585,7 +3567,6 @@
               <a:rPr kumimoji="1" lang="en-US" altLang="ja-JP"/>
               <a:t>Third level</a:t>
             </a:r>
-            <a:endParaRPr kumimoji="1" lang="en-US" altLang="ja-JP"/>
           </a:p>
           <a:p>
             <a:pPr lvl="3"/>
@@ -3593,7 +3574,6 @@
               <a:rPr kumimoji="1" lang="en-US" altLang="ja-JP"/>
               <a:t>Fourth level</a:t>
             </a:r>
-            <a:endParaRPr kumimoji="1" lang="en-US" altLang="ja-JP"/>
           </a:p>
           <a:p>
             <a:pPr lvl="4"/>
@@ -3622,6 +3602,7 @@
           <a:p>
             <a:fld id="{AE545288-4E63-4A9A-9FF7-11823647D6C9}" type="datetimeFigureOut">
               <a:rPr kumimoji="1" lang="ja-JP" altLang="en-US" smtClean="0"/>
+              <a:t>2026/8/30</a:t>
             </a:fld>
             <a:endParaRPr kumimoji="1" lang="ja-JP" altLang="en-US"/>
           </a:p>
@@ -3663,6 +3644,7 @@
           <a:p>
             <a:fld id="{19167D3B-9FB3-4BD5-BAC9-DA5EEE515399}" type="slidenum">
               <a:rPr kumimoji="1" lang="ja-JP" altLang="en-US" smtClean="0"/>
+              <a:t>‹#›</a:t>
             </a:fld>
             <a:endParaRPr kumimoji="1" lang="ja-JP" altLang="en-US"/>
           </a:p>
@@ -3841,7 +3823,6 @@
               <a:rPr kumimoji="1" lang="en-US" altLang="ja-JP"/>
               <a:t>Click to edit Master text styles</a:t>
             </a:r>
-            <a:endParaRPr kumimoji="1" lang="en-US" altLang="ja-JP"/>
           </a:p>
         </p:txBody>
       </p:sp>
@@ -3862,6 +3843,7 @@
           <a:p>
             <a:fld id="{AE545288-4E63-4A9A-9FF7-11823647D6C9}" type="datetimeFigureOut">
               <a:rPr kumimoji="1" lang="ja-JP" altLang="en-US" smtClean="0"/>
+              <a:t>2026/8/30</a:t>
             </a:fld>
             <a:endParaRPr kumimoji="1" lang="ja-JP" altLang="en-US"/>
           </a:p>
@@ -3903,6 +3885,7 @@
           <a:p>
             <a:fld id="{19167D3B-9FB3-4BD5-BAC9-DA5EEE515399}" type="slidenum">
               <a:rPr kumimoji="1" lang="ja-JP" altLang="en-US" smtClean="0"/>
+              <a:t>‹#›</a:t>
             </a:fld>
             <a:endParaRPr kumimoji="1" lang="ja-JP" altLang="en-US"/>
           </a:p>
@@ -3981,7 +3964,6 @@
               <a:rPr kumimoji="1" lang="en-US" altLang="ja-JP"/>
               <a:t>Click to edit Master text styles</a:t>
             </a:r>
-            <a:endParaRPr kumimoji="1" lang="en-US" altLang="ja-JP"/>
           </a:p>
           <a:p>
             <a:pPr lvl="1"/>
@@ -3989,7 +3971,6 @@
               <a:rPr kumimoji="1" lang="en-US" altLang="ja-JP"/>
               <a:t>Second level</a:t>
             </a:r>
-            <a:endParaRPr kumimoji="1" lang="en-US" altLang="ja-JP"/>
           </a:p>
           <a:p>
             <a:pPr lvl="2"/>
@@ -3997,7 +3978,6 @@
               <a:rPr kumimoji="1" lang="en-US" altLang="ja-JP"/>
               <a:t>Third level</a:t>
             </a:r>
-            <a:endParaRPr kumimoji="1" lang="en-US" altLang="ja-JP"/>
           </a:p>
           <a:p>
             <a:pPr lvl="3"/>
@@ -4005,7 +3985,6 @@
               <a:rPr kumimoji="1" lang="en-US" altLang="ja-JP"/>
               <a:t>Fourth level</a:t>
             </a:r>
-            <a:endParaRPr kumimoji="1" lang="en-US" altLang="ja-JP"/>
           </a:p>
           <a:p>
             <a:pPr lvl="4"/>
@@ -4042,7 +4021,6 @@
               <a:rPr kumimoji="1" lang="en-US" altLang="ja-JP"/>
               <a:t>Click to edit Master text styles</a:t>
             </a:r>
-            <a:endParaRPr kumimoji="1" lang="en-US" altLang="ja-JP"/>
           </a:p>
           <a:p>
             <a:pPr lvl="1"/>
@@ -4050,7 +4028,6 @@
               <a:rPr kumimoji="1" lang="en-US" altLang="ja-JP"/>
               <a:t>Second level</a:t>
             </a:r>
-            <a:endParaRPr kumimoji="1" lang="en-US" altLang="ja-JP"/>
           </a:p>
           <a:p>
             <a:pPr lvl="2"/>
@@ -4058,7 +4035,6 @@
               <a:rPr kumimoji="1" lang="en-US" altLang="ja-JP"/>
               <a:t>Third level</a:t>
             </a:r>
-            <a:endParaRPr kumimoji="1" lang="en-US" altLang="ja-JP"/>
           </a:p>
           <a:p>
             <a:pPr lvl="3"/>
@@ -4066,7 +4042,6 @@
               <a:rPr kumimoji="1" lang="en-US" altLang="ja-JP"/>
               <a:t>Fourth level</a:t>
             </a:r>
-            <a:endParaRPr kumimoji="1" lang="en-US" altLang="ja-JP"/>
           </a:p>
           <a:p>
             <a:pPr lvl="4"/>
@@ -4095,6 +4070,7 @@
           <a:p>
             <a:fld id="{AE545288-4E63-4A9A-9FF7-11823647D6C9}" type="datetimeFigureOut">
               <a:rPr kumimoji="1" lang="ja-JP" altLang="en-US" smtClean="0"/>
+              <a:t>2026/8/30</a:t>
             </a:fld>
             <a:endParaRPr kumimoji="1" lang="ja-JP" altLang="en-US"/>
           </a:p>
@@ -4136,6 +4112,7 @@
           <a:p>
             <a:fld id="{19167D3B-9FB3-4BD5-BAC9-DA5EEE515399}" type="slidenum">
               <a:rPr kumimoji="1" lang="ja-JP" altLang="en-US" smtClean="0"/>
+              <a:t>‹#›</a:t>
             </a:fld>
             <a:endParaRPr kumimoji="1" lang="ja-JP" altLang="en-US"/>
           </a:p>
@@ -4256,7 +4233,6 @@
               <a:rPr kumimoji="1" lang="en-US" altLang="ja-JP"/>
               <a:t>Click to edit Master text styles</a:t>
             </a:r>
-            <a:endParaRPr kumimoji="1" lang="en-US" altLang="ja-JP"/>
           </a:p>
         </p:txBody>
       </p:sp>
@@ -4285,7 +4261,6 @@
               <a:rPr kumimoji="1" lang="en-US" altLang="ja-JP"/>
               <a:t>Click to edit Master text styles</a:t>
             </a:r>
-            <a:endParaRPr kumimoji="1" lang="en-US" altLang="ja-JP"/>
           </a:p>
           <a:p>
             <a:pPr lvl="1"/>
@@ -4293,7 +4268,6 @@
               <a:rPr kumimoji="1" lang="en-US" altLang="ja-JP"/>
               <a:t>Second level</a:t>
             </a:r>
-            <a:endParaRPr kumimoji="1" lang="en-US" altLang="ja-JP"/>
           </a:p>
           <a:p>
             <a:pPr lvl="2"/>
@@ -4301,7 +4275,6 @@
               <a:rPr kumimoji="1" lang="en-US" altLang="ja-JP"/>
               <a:t>Third level</a:t>
             </a:r>
-            <a:endParaRPr kumimoji="1" lang="en-US" altLang="ja-JP"/>
           </a:p>
           <a:p>
             <a:pPr lvl="3"/>
@@ -4309,7 +4282,6 @@
               <a:rPr kumimoji="1" lang="en-US" altLang="ja-JP"/>
               <a:t>Fourth level</a:t>
             </a:r>
-            <a:endParaRPr kumimoji="1" lang="en-US" altLang="ja-JP"/>
           </a:p>
           <a:p>
             <a:pPr lvl="4"/>
@@ -4383,7 +4355,6 @@
               <a:rPr kumimoji="1" lang="en-US" altLang="ja-JP"/>
               <a:t>Click to edit Master text styles</a:t>
             </a:r>
-            <a:endParaRPr kumimoji="1" lang="en-US" altLang="ja-JP"/>
           </a:p>
         </p:txBody>
       </p:sp>
@@ -4412,7 +4383,6 @@
               <a:rPr kumimoji="1" lang="en-US" altLang="ja-JP"/>
               <a:t>Click to edit Master text styles</a:t>
             </a:r>
-            <a:endParaRPr kumimoji="1" lang="en-US" altLang="ja-JP"/>
           </a:p>
           <a:p>
             <a:pPr lvl="1"/>
@@ -4420,7 +4390,6 @@
               <a:rPr kumimoji="1" lang="en-US" altLang="ja-JP"/>
               <a:t>Second level</a:t>
             </a:r>
-            <a:endParaRPr kumimoji="1" lang="en-US" altLang="ja-JP"/>
           </a:p>
           <a:p>
             <a:pPr lvl="2"/>
@@ -4428,7 +4397,6 @@
               <a:rPr kumimoji="1" lang="en-US" altLang="ja-JP"/>
               <a:t>Third level</a:t>
             </a:r>
-            <a:endParaRPr kumimoji="1" lang="en-US" altLang="ja-JP"/>
           </a:p>
           <a:p>
             <a:pPr lvl="3"/>
@@ -4436,7 +4404,6 @@
               <a:rPr kumimoji="1" lang="en-US" altLang="ja-JP"/>
               <a:t>Fourth level</a:t>
             </a:r>
-            <a:endParaRPr kumimoji="1" lang="en-US" altLang="ja-JP"/>
           </a:p>
           <a:p>
             <a:pPr lvl="4"/>
@@ -4465,6 +4432,7 @@
           <a:p>
             <a:fld id="{AE545288-4E63-4A9A-9FF7-11823647D6C9}" type="datetimeFigureOut">
               <a:rPr kumimoji="1" lang="ja-JP" altLang="en-US" smtClean="0"/>
+              <a:t>2026/8/30</a:t>
             </a:fld>
             <a:endParaRPr kumimoji="1" lang="ja-JP" altLang="en-US"/>
           </a:p>
@@ -4506,6 +4474,7 @@
           <a:p>
             <a:fld id="{19167D3B-9FB3-4BD5-BAC9-DA5EEE515399}" type="slidenum">
               <a:rPr kumimoji="1" lang="ja-JP" altLang="en-US" smtClean="0"/>
+              <a:t>‹#›</a:t>
             </a:fld>
             <a:endParaRPr kumimoji="1" lang="ja-JP" altLang="en-US"/>
           </a:p>
@@ -4576,6 +4545,7 @@
           <a:p>
             <a:fld id="{AE545288-4E63-4A9A-9FF7-11823647D6C9}" type="datetimeFigureOut">
               <a:rPr kumimoji="1" lang="ja-JP" altLang="en-US" smtClean="0"/>
+              <a:t>2026/8/30</a:t>
             </a:fld>
             <a:endParaRPr kumimoji="1" lang="ja-JP" altLang="en-US"/>
           </a:p>
@@ -4617,6 +4587,7 @@
           <a:p>
             <a:fld id="{19167D3B-9FB3-4BD5-BAC9-DA5EEE515399}" type="slidenum">
               <a:rPr kumimoji="1" lang="ja-JP" altLang="en-US" smtClean="0"/>
+              <a:t>‹#›</a:t>
             </a:fld>
             <a:endParaRPr kumimoji="1" lang="ja-JP" altLang="en-US"/>
           </a:p>
@@ -4664,6 +4635,7 @@
           <a:p>
             <a:fld id="{AE545288-4E63-4A9A-9FF7-11823647D6C9}" type="datetimeFigureOut">
               <a:rPr kumimoji="1" lang="ja-JP" altLang="en-US" smtClean="0"/>
+              <a:t>2026/8/30</a:t>
             </a:fld>
             <a:endParaRPr kumimoji="1" lang="ja-JP" altLang="en-US"/>
           </a:p>
@@ -4705,6 +4677,7 @@
           <a:p>
             <a:fld id="{19167D3B-9FB3-4BD5-BAC9-DA5EEE515399}" type="slidenum">
               <a:rPr kumimoji="1" lang="ja-JP" altLang="en-US" smtClean="0"/>
+              <a:t>‹#›</a:t>
             </a:fld>
             <a:endParaRPr kumimoji="1" lang="ja-JP" altLang="en-US"/>
           </a:p>
@@ -4820,7 +4793,6 @@
               <a:rPr kumimoji="1" lang="en-US" altLang="ja-JP"/>
               <a:t>Click to edit Master text styles</a:t>
             </a:r>
-            <a:endParaRPr kumimoji="1" lang="en-US" altLang="ja-JP"/>
           </a:p>
           <a:p>
             <a:pPr lvl="1"/>
@@ -4828,7 +4800,6 @@
               <a:rPr kumimoji="1" lang="en-US" altLang="ja-JP"/>
               <a:t>Second level</a:t>
             </a:r>
-            <a:endParaRPr kumimoji="1" lang="en-US" altLang="ja-JP"/>
           </a:p>
           <a:p>
             <a:pPr lvl="2"/>
@@ -4836,7 +4807,6 @@
               <a:rPr kumimoji="1" lang="en-US" altLang="ja-JP"/>
               <a:t>Third level</a:t>
             </a:r>
-            <a:endParaRPr kumimoji="1" lang="en-US" altLang="ja-JP"/>
           </a:p>
           <a:p>
             <a:pPr lvl="3"/>
@@ -4844,7 +4814,6 @@
               <a:rPr kumimoji="1" lang="en-US" altLang="ja-JP"/>
               <a:t>Fourth level</a:t>
             </a:r>
-            <a:endParaRPr kumimoji="1" lang="en-US" altLang="ja-JP"/>
           </a:p>
           <a:p>
             <a:pPr lvl="4"/>
@@ -4918,7 +4887,6 @@
               <a:rPr kumimoji="1" lang="en-US" altLang="ja-JP"/>
               <a:t>Click to edit Master text styles</a:t>
             </a:r>
-            <a:endParaRPr kumimoji="1" lang="en-US" altLang="ja-JP"/>
           </a:p>
         </p:txBody>
       </p:sp>
@@ -4939,6 +4907,7 @@
           <a:p>
             <a:fld id="{AE545288-4E63-4A9A-9FF7-11823647D6C9}" type="datetimeFigureOut">
               <a:rPr kumimoji="1" lang="ja-JP" altLang="en-US" smtClean="0"/>
+              <a:t>2026/8/30</a:t>
             </a:fld>
             <a:endParaRPr kumimoji="1" lang="ja-JP" altLang="en-US"/>
           </a:p>
@@ -4980,6 +4949,7 @@
           <a:p>
             <a:fld id="{19167D3B-9FB3-4BD5-BAC9-DA5EEE515399}" type="slidenum">
               <a:rPr kumimoji="1" lang="ja-JP" altLang="en-US" smtClean="0"/>
+              <a:t>‹#›</a:t>
             </a:fld>
             <a:endParaRPr kumimoji="1" lang="ja-JP" altLang="en-US"/>
           </a:p>
@@ -5165,7 +5135,6 @@
               <a:rPr kumimoji="1" lang="en-US" altLang="ja-JP"/>
               <a:t>Click to edit Master text styles</a:t>
             </a:r>
-            <a:endParaRPr kumimoji="1" lang="en-US" altLang="ja-JP"/>
           </a:p>
         </p:txBody>
       </p:sp>
@@ -5186,6 +5155,7 @@
           <a:p>
             <a:fld id="{AE545288-4E63-4A9A-9FF7-11823647D6C9}" type="datetimeFigureOut">
               <a:rPr kumimoji="1" lang="ja-JP" altLang="en-US" smtClean="0"/>
+              <a:t>2026/8/30</a:t>
             </a:fld>
             <a:endParaRPr kumimoji="1" lang="ja-JP" altLang="en-US"/>
           </a:p>
@@ -5227,6 +5197,7 @@
           <a:p>
             <a:fld id="{19167D3B-9FB3-4BD5-BAC9-DA5EEE515399}" type="slidenum">
               <a:rPr kumimoji="1" lang="ja-JP" altLang="en-US" smtClean="0"/>
+              <a:t>‹#›</a:t>
             </a:fld>
             <a:endParaRPr kumimoji="1" lang="ja-JP" altLang="en-US"/>
           </a:p>
@@ -5325,7 +5296,6 @@
               <a:rPr kumimoji="1" lang="en-US" altLang="ja-JP"/>
               <a:t>Click to edit Master text styles</a:t>
             </a:r>
-            <a:endParaRPr kumimoji="1" lang="en-US" altLang="ja-JP"/>
           </a:p>
           <a:p>
             <a:pPr lvl="1"/>
@@ -5333,7 +5303,6 @@
               <a:rPr kumimoji="1" lang="en-US" altLang="ja-JP"/>
               <a:t>Second level</a:t>
             </a:r>
-            <a:endParaRPr kumimoji="1" lang="en-US" altLang="ja-JP"/>
           </a:p>
           <a:p>
             <a:pPr lvl="2"/>
@@ -5341,7 +5310,6 @@
               <a:rPr kumimoji="1" lang="en-US" altLang="ja-JP"/>
               <a:t>Third level</a:t>
             </a:r>
-            <a:endParaRPr kumimoji="1" lang="en-US" altLang="ja-JP"/>
           </a:p>
           <a:p>
             <a:pPr lvl="3"/>
@@ -5349,7 +5317,6 @@
               <a:rPr kumimoji="1" lang="en-US" altLang="ja-JP"/>
               <a:t>Fourth level</a:t>
             </a:r>
-            <a:endParaRPr kumimoji="1" lang="en-US" altLang="ja-JP"/>
           </a:p>
           <a:p>
             <a:pPr lvl="4"/>
@@ -5396,6 +5363,7 @@
           <a:p>
             <a:fld id="{AE545288-4E63-4A9A-9FF7-11823647D6C9}" type="datetimeFigureOut">
               <a:rPr kumimoji="1" lang="ja-JP" altLang="en-US" smtClean="0"/>
+              <a:t>2026/8/30</a:t>
             </a:fld>
             <a:endParaRPr kumimoji="1" lang="ja-JP" altLang="en-US"/>
           </a:p>
@@ -5473,6 +5441,7 @@
           <a:p>
             <a:fld id="{19167D3B-9FB3-4BD5-BAC9-DA5EEE515399}" type="slidenum">
               <a:rPr kumimoji="1" lang="ja-JP" altLang="en-US" smtClean="0"/>
+              <a:t>‹#›</a:t>
             </a:fld>
             <a:endParaRPr kumimoji="1" lang="ja-JP" altLang="en-US"/>
           </a:p>
@@ -5862,7 +5831,6 @@
               <a:rPr kumimoji="1" lang="en-US" altLang="ja-JP"/>
               <a:t>Click to edit Master text styles</a:t>
             </a:r>
-            <a:endParaRPr kumimoji="1" lang="en-US" altLang="ja-JP"/>
           </a:p>
           <a:p>
             <a:pPr lvl="1"/>
@@ -5870,7 +5838,6 @@
               <a:rPr kumimoji="1" lang="en-US" altLang="ja-JP"/>
               <a:t>Second level</a:t>
             </a:r>
-            <a:endParaRPr kumimoji="1" lang="en-US" altLang="ja-JP"/>
           </a:p>
           <a:p>
             <a:pPr lvl="2"/>
@@ -5878,7 +5845,6 @@
               <a:rPr kumimoji="1" lang="en-US" altLang="ja-JP"/>
               <a:t>Third level</a:t>
             </a:r>
-            <a:endParaRPr kumimoji="1" lang="en-US" altLang="ja-JP"/>
           </a:p>
           <a:p>
             <a:pPr lvl="3"/>
@@ -5886,7 +5852,6 @@
               <a:rPr kumimoji="1" lang="en-US" altLang="ja-JP"/>
               <a:t>Fourth level</a:t>
             </a:r>
-            <a:endParaRPr kumimoji="1" lang="en-US" altLang="ja-JP"/>
           </a:p>
           <a:p>
             <a:pPr lvl="4"/>
@@ -5933,6 +5898,7 @@
           <a:p>
             <a:fld id="{AE545288-4E63-4A9A-9FF7-11823647D6C9}" type="datetimeFigureOut">
               <a:rPr kumimoji="1" lang="ja-JP" altLang="en-US" smtClean="0"/>
+              <a:t>2026/8/30</a:t>
             </a:fld>
             <a:endParaRPr kumimoji="1" lang="ja-JP" altLang="en-US"/>
           </a:p>
@@ -6010,6 +5976,7 @@
           <a:p>
             <a:fld id="{19167D3B-9FB3-4BD5-BAC9-DA5EEE515399}" type="slidenum">
               <a:rPr kumimoji="1" lang="ja-JP" altLang="en-US" smtClean="0"/>
+              <a:t>‹#›</a:t>
             </a:fld>
             <a:endParaRPr kumimoji="1" lang="ja-JP" altLang="en-US"/>
           </a:p>
@@ -6361,7 +6328,6 @@
               <a:rPr lang="ja-JP" altLang="en-US" sz="1100" dirty="0"/>
               <a:t>https://huggingface.co/learn/llm-course/en/chapter1/4</a:t>
             </a:r>
-            <a:endParaRPr lang="ja-JP" altLang="en-US" sz="1100" dirty="0"/>
           </a:p>
         </p:txBody>
       </p:sp>
@@ -6411,7 +6377,7 @@
           <p:nvPr/>
         </p:nvPicPr>
         <p:blipFill>
-          <a:blip r:embed="rId1"/>
+          <a:blip r:embed="rId2"/>
           <a:stretch>
             <a:fillRect/>
           </a:stretch>
@@ -6487,11 +6453,6 @@
               </a:rPr>
               <a:t>.</a:t>
             </a:r>
-            <a:endParaRPr lang="en-US" altLang="ja-JP" sz="1600" dirty="0">
-              <a:latin typeface="Calibri Light" panose="020F0302020204030204" pitchFamily="34" charset="0"/>
-              <a:ea typeface="Calibri Light" panose="020F0302020204030204" pitchFamily="34" charset="0"/>
-              <a:cs typeface="Calibri Light" panose="020F0302020204030204" pitchFamily="34" charset="0"/>
-            </a:endParaRPr>
           </a:p>
           <a:p>
             <a:pPr marL="285750" indent="-285750">
@@ -6560,7 +6521,7 @@
           <p:nvPr/>
         </p:nvPicPr>
         <p:blipFill>
-          <a:blip r:embed="rId2"/>
+          <a:blip r:embed="rId3"/>
           <a:stretch>
             <a:fillRect/>
           </a:stretch>
@@ -6604,10 +6565,6 @@
               </a:rPr>
               <a:t>["i", "like", "books"]</a:t>
             </a:r>
-            <a:endParaRPr lang="ja-JP" altLang="en-US" sz="1600" dirty="0">
-              <a:latin typeface="Calibri Light" panose="020F0302020204030204" pitchFamily="34" charset="0"/>
-              <a:cs typeface="Calibri Light" panose="020F0302020204030204" pitchFamily="34" charset="0"/>
-            </a:endParaRPr>
           </a:p>
         </p:txBody>
       </p:sp>
@@ -6640,10 +6597,6 @@
               </a:rPr>
               <a:t>["&lt;sos&gt;", "i", "like", "books"]</a:t>
             </a:r>
-            <a:endParaRPr lang="ja-JP" altLang="en-US" sz="1600" dirty="0">
-              <a:latin typeface="Calibri Light" panose="020F0302020204030204" pitchFamily="34" charset="0"/>
-              <a:cs typeface="Calibri Light" panose="020F0302020204030204" pitchFamily="34" charset="0"/>
-            </a:endParaRPr>
           </a:p>
         </p:txBody>
       </p:sp>
@@ -6946,7 +6899,7 @@
           <p:nvPr/>
         </p:nvPicPr>
         <p:blipFill>
-          <a:blip r:embed="rId1"/>
+          <a:blip r:embed="rId2"/>
           <a:stretch>
             <a:fillRect/>
           </a:stretch>
@@ -7131,14 +7084,6 @@
               </a:rPr>
               <a:t>: (word): Scores</a:t>
             </a:r>
-            <a:endParaRPr kumimoji="1" lang="en-US" altLang="ja-JP" sz="1400" dirty="0">
-              <a:solidFill>
-                <a:schemeClr val="tx1"/>
-              </a:solidFill>
-              <a:latin typeface="Calibri Light" panose="020F0302020204030204" pitchFamily="34" charset="0"/>
-              <a:ea typeface="Calibri Light" panose="020F0302020204030204" pitchFamily="34" charset="0"/>
-              <a:cs typeface="Calibri Light" panose="020F0302020204030204" pitchFamily="34" charset="0"/>
-            </a:endParaRPr>
           </a:p>
         </p:txBody>
       </p:sp>
@@ -7172,11 +7117,6 @@
               </a:rPr>
               <a:t>Objectives:</a:t>
             </a:r>
-            <a:endParaRPr kumimoji="1" lang="en-US" altLang="ja-JP" sz="1400" b="1" dirty="0">
-              <a:latin typeface="Calibri Light" panose="020F0302020204030204" pitchFamily="34" charset="0"/>
-              <a:ea typeface="Calibri Light" panose="020F0302020204030204" pitchFamily="34" charset="0"/>
-              <a:cs typeface="Calibri Light" panose="020F0302020204030204" pitchFamily="34" charset="0"/>
-            </a:endParaRPr>
           </a:p>
           <a:p>
             <a:pPr marL="285750" indent="-285750">
@@ -7208,12 +7148,6 @@
               </a:rPr>
               <a:t> Builds the Lexicon.</a:t>
             </a:r>
-            <a:endParaRPr kumimoji="1" lang="en-US" altLang="ja-JP" sz="1400" dirty="0">
-              <a:latin typeface="Calibri Light" panose="020F0302020204030204" pitchFamily="34" charset="0"/>
-              <a:ea typeface="Calibri Light" panose="020F0302020204030204" pitchFamily="34" charset="0"/>
-              <a:cs typeface="Calibri Light" panose="020F0302020204030204" pitchFamily="34" charset="0"/>
-              <a:sym typeface="Wingdings" panose="05000000000000000000" pitchFamily="2" charset="2"/>
-            </a:endParaRPr>
           </a:p>
           <a:p>
             <a:pPr marL="285750" indent="-285750">
@@ -7292,14 +7226,6 @@
               </a:rPr>
               <a:t>Measures how tightly  the characters in the word sticks together (left to right). High value means it’s likely an actual word</a:t>
             </a:r>
-            <a:endParaRPr kumimoji="1" lang="en-US" altLang="ja-JP" sz="1400" dirty="0">
-              <a:solidFill>
-                <a:schemeClr val="tx1"/>
-              </a:solidFill>
-              <a:latin typeface="Calibri Light" panose="020F0302020204030204" pitchFamily="34" charset="0"/>
-              <a:ea typeface="Calibri Light" panose="020F0302020204030204" pitchFamily="34" charset="0"/>
-              <a:cs typeface="Calibri Light" panose="020F0302020204030204" pitchFamily="34" charset="0"/>
-            </a:endParaRPr>
           </a:p>
         </p:txBody>
       </p:sp>
@@ -7361,7 +7287,7 @@
           <p:nvPr/>
         </p:nvPicPr>
         <p:blipFill>
-          <a:blip r:embed="rId2"/>
+          <a:blip r:embed="rId3"/>
           <a:stretch>
             <a:fillRect/>
           </a:stretch>
@@ -7578,6 +7504,117 @@
               </a:rPr>
               <a:t> stands for Left tokenizer:</a:t>
             </a:r>
+          </a:p>
+          <a:p>
+            <a:pPr marL="285750" indent="-285750">
+              <a:buFont typeface="Arial" panose="020B0604020202090204" pitchFamily="34" charset="0"/>
+              <a:buChar char="•"/>
+            </a:pPr>
+            <a:r>
+              <a:rPr kumimoji="1" lang="en-US" altLang="ja-JP" sz="1400" dirty="0">
+                <a:solidFill>
+                  <a:schemeClr val="tx1"/>
+                </a:solidFill>
+                <a:latin typeface="Calibri Light" panose="020F0302020204030204" pitchFamily="34" charset="0"/>
+                <a:ea typeface="Calibri Light" panose="020F0302020204030204" pitchFamily="34" charset="0"/>
+                <a:cs typeface="Calibri Light" panose="020F0302020204030204" pitchFamily="34" charset="0"/>
+              </a:rPr>
+              <a:t>L + [R] → Left part (main word) + Right part (optional particle or suffix)</a:t>
+            </a:r>
+            <a:r>
+              <a:rPr lang="en-US" altLang="ja-JP" sz="1400" dirty="0">
+                <a:solidFill>
+                  <a:schemeClr val="tx1"/>
+                </a:solidFill>
+                <a:latin typeface="Calibri Light" panose="020F0302020204030204" pitchFamily="34" charset="0"/>
+                <a:ea typeface="Calibri Light" panose="020F0302020204030204" pitchFamily="34" charset="0"/>
+                <a:cs typeface="Calibri Light" panose="020F0302020204030204" pitchFamily="34" charset="0"/>
+              </a:rPr>
+              <a:t>.</a:t>
+            </a:r>
+          </a:p>
+          <a:p>
+            <a:pPr marL="285750" indent="-285750">
+              <a:buFont typeface="Arial" panose="020B0604020202090204" pitchFamily="34" charset="0"/>
+              <a:buChar char="•"/>
+            </a:pPr>
+            <a:r>
+              <a:rPr kumimoji="1" lang="en-US" altLang="ko-KR" sz="1400" dirty="0">
+                <a:solidFill>
+                  <a:schemeClr val="tx1"/>
+                </a:solidFill>
+                <a:latin typeface="Calibri Light" panose="020F0302020204030204" pitchFamily="34" charset="0"/>
+                <a:ea typeface="Calibri Light" panose="020F0302020204030204" pitchFamily="34" charset="0"/>
+                <a:cs typeface="Calibri Light" panose="020F0302020204030204" pitchFamily="34" charset="0"/>
+              </a:rPr>
+              <a:t>E.g.: "</a:t>
+            </a:r>
+            <a:r>
+              <a:rPr kumimoji="1" lang="ko-KR" altLang="en-US" sz="1400" dirty="0">
+                <a:solidFill>
+                  <a:schemeClr val="tx1"/>
+                </a:solidFill>
+                <a:latin typeface="Calibri Light" panose="020F0302020204030204" pitchFamily="34" charset="0"/>
+                <a:ea typeface="Calibri Light" panose="020F0302020204030204" pitchFamily="34" charset="0"/>
+                <a:cs typeface="Calibri Light" panose="020F0302020204030204" pitchFamily="34" charset="0"/>
+              </a:rPr>
+              <a:t>학생이</a:t>
+            </a:r>
+            <a:r>
+              <a:rPr kumimoji="1" lang="en-US" altLang="ko-KR" sz="1400" dirty="0">
+                <a:solidFill>
+                  <a:schemeClr val="tx1"/>
+                </a:solidFill>
+                <a:latin typeface="Calibri Light" panose="020F0302020204030204" pitchFamily="34" charset="0"/>
+                <a:ea typeface="Calibri Light" panose="020F0302020204030204" pitchFamily="34" charset="0"/>
+                <a:cs typeface="Calibri Light" panose="020F0302020204030204" pitchFamily="34" charset="0"/>
+              </a:rPr>
+              <a:t>" → "</a:t>
+            </a:r>
+            <a:r>
+              <a:rPr kumimoji="1" lang="ko-KR" altLang="en-US" sz="1400" dirty="0">
+                <a:solidFill>
+                  <a:schemeClr val="tx1"/>
+                </a:solidFill>
+                <a:latin typeface="Calibri Light" panose="020F0302020204030204" pitchFamily="34" charset="0"/>
+                <a:ea typeface="Calibri Light" panose="020F0302020204030204" pitchFamily="34" charset="0"/>
+                <a:cs typeface="Calibri Light" panose="020F0302020204030204" pitchFamily="34" charset="0"/>
+              </a:rPr>
+              <a:t>학생</a:t>
+            </a:r>
+            <a:r>
+              <a:rPr kumimoji="1" lang="en-US" altLang="ko-KR" sz="1400" dirty="0">
+                <a:solidFill>
+                  <a:schemeClr val="tx1"/>
+                </a:solidFill>
+                <a:latin typeface="Calibri Light" panose="020F0302020204030204" pitchFamily="34" charset="0"/>
+                <a:ea typeface="Calibri Light" panose="020F0302020204030204" pitchFamily="34" charset="0"/>
+                <a:cs typeface="Calibri Light" panose="020F0302020204030204" pitchFamily="34" charset="0"/>
+              </a:rPr>
+              <a:t>" (L) + "</a:t>
+            </a:r>
+            <a:r>
+              <a:rPr kumimoji="1" lang="ko-KR" altLang="en-US" sz="1400" dirty="0">
+                <a:solidFill>
+                  <a:schemeClr val="tx1"/>
+                </a:solidFill>
+                <a:latin typeface="Calibri Light" panose="020F0302020204030204" pitchFamily="34" charset="0"/>
+                <a:ea typeface="Calibri Light" panose="020F0302020204030204" pitchFamily="34" charset="0"/>
+                <a:cs typeface="Calibri Light" panose="020F0302020204030204" pitchFamily="34" charset="0"/>
+              </a:rPr>
+              <a:t>이</a:t>
+            </a:r>
+            <a:r>
+              <a:rPr kumimoji="1" lang="en-US" altLang="ko-KR" sz="1400" dirty="0">
+                <a:solidFill>
+                  <a:schemeClr val="tx1"/>
+                </a:solidFill>
+                <a:latin typeface="Calibri Light" panose="020F0302020204030204" pitchFamily="34" charset="0"/>
+                <a:ea typeface="Calibri Light" panose="020F0302020204030204" pitchFamily="34" charset="0"/>
+                <a:cs typeface="Calibri Light" panose="020F0302020204030204" pitchFamily="34" charset="0"/>
+              </a:rPr>
+              <a:t>" (R)</a:t>
+            </a:r>
             <a:endParaRPr kumimoji="1" lang="en-US" altLang="ja-JP" sz="1400" dirty="0">
               <a:solidFill>
                 <a:schemeClr val="tx1"/>
@@ -7587,212 +7624,72 @@
               <a:cs typeface="Calibri Light" panose="020F0302020204030204" pitchFamily="34" charset="0"/>
             </a:endParaRPr>
           </a:p>
+        </p:txBody>
+      </p:sp>
+      <p:sp>
+        <p:nvSpPr>
+          <p:cNvPr id="20" name="TextBox 19"/>
+          <p:cNvSpPr txBox="1"/>
+          <p:nvPr/>
+        </p:nvSpPr>
+        <p:spPr>
+          <a:xfrm>
+            <a:off x="6315074" y="3731320"/>
+            <a:ext cx="3609975" cy="523220"/>
+          </a:xfrm>
+          <a:prstGeom prst="rect">
+            <a:avLst/>
+          </a:prstGeom>
+          <a:noFill/>
+        </p:spPr>
+        <p:txBody>
+          <a:bodyPr wrap="square" rtlCol="0">
+            <a:spAutoFit/>
+          </a:bodyPr>
+          <a:lstStyle/>
+          <a:p>
+            <a:r>
+              <a:rPr kumimoji="1" lang="en-US" altLang="ja-JP" sz="1400" b="1" dirty="0">
+                <a:solidFill>
+                  <a:srgbClr val="FF0000"/>
+                </a:solidFill>
+                <a:latin typeface="Calibri Light" panose="020F0302020204030204" pitchFamily="34" charset="0"/>
+                <a:ea typeface="Calibri Light" panose="020F0302020204030204" pitchFamily="34" charset="0"/>
+                <a:cs typeface="Calibri Light" panose="020F0302020204030204" pitchFamily="34" charset="0"/>
+              </a:rPr>
+              <a:t>Notes:</a:t>
+            </a:r>
+          </a:p>
           <a:p>
             <a:pPr marL="285750" indent="-285750">
               <a:buFont typeface="Arial" panose="020B0604020202090204" pitchFamily="34" charset="0"/>
               <a:buChar char="•"/>
             </a:pPr>
             <a:r>
-              <a:rPr kumimoji="1" lang="en-US" altLang="ja-JP" sz="1400" dirty="0">
-                <a:solidFill>
-                  <a:schemeClr val="tx1"/>
-                </a:solidFill>
-                <a:latin typeface="Calibri Light" panose="020F0302020204030204" pitchFamily="34" charset="0"/>
-                <a:ea typeface="Calibri Light" panose="020F0302020204030204" pitchFamily="34" charset="0"/>
-                <a:cs typeface="Calibri Light" panose="020F0302020204030204" pitchFamily="34" charset="0"/>
-              </a:rPr>
-              <a:t>L + [R] → Left part (main word) + Right part (optional particle or suffix)</a:t>
-            </a:r>
-            <a:r>
               <a:rPr lang="en-US" altLang="ja-JP" sz="1400" dirty="0">
-                <a:solidFill>
-                  <a:schemeClr val="tx1"/>
-                </a:solidFill>
-                <a:latin typeface="Calibri Light" panose="020F0302020204030204" pitchFamily="34" charset="0"/>
-                <a:ea typeface="Calibri Light" panose="020F0302020204030204" pitchFamily="34" charset="0"/>
-                <a:cs typeface="Calibri Light" panose="020F0302020204030204" pitchFamily="34" charset="0"/>
-              </a:rPr>
-              <a:t>.</a:t>
-            </a:r>
-            <a:endParaRPr lang="en-US" altLang="ja-JP" sz="1400" dirty="0">
-              <a:solidFill>
-                <a:schemeClr val="tx1"/>
-              </a:solidFill>
-              <a:latin typeface="Calibri Light" panose="020F0302020204030204" pitchFamily="34" charset="0"/>
-              <a:ea typeface="Calibri Light" panose="020F0302020204030204" pitchFamily="34" charset="0"/>
-              <a:cs typeface="Calibri Light" panose="020F0302020204030204" pitchFamily="34" charset="0"/>
-            </a:endParaRPr>
-          </a:p>
-          <a:p>
-            <a:pPr marL="285750" indent="-285750">
-              <a:buFont typeface="Arial" panose="020B0604020202090204" pitchFamily="34" charset="0"/>
-              <a:buChar char="•"/>
-            </a:pPr>
-            <a:r>
-              <a:rPr kumimoji="1" lang="en-US" altLang="ko-KR" sz="1400" dirty="0">
-                <a:solidFill>
-                  <a:schemeClr val="tx1"/>
-                </a:solidFill>
-                <a:latin typeface="Calibri Light" panose="020F0302020204030204" pitchFamily="34" charset="0"/>
-                <a:ea typeface="Calibri Light" panose="020F0302020204030204" pitchFamily="34" charset="0"/>
-                <a:cs typeface="Calibri Light" panose="020F0302020204030204" pitchFamily="34" charset="0"/>
-              </a:rPr>
-              <a:t>E.g.: "</a:t>
-            </a:r>
-            <a:r>
-              <a:rPr kumimoji="1" lang="ko-KR" altLang="en-US" sz="1400" dirty="0">
-                <a:solidFill>
-                  <a:schemeClr val="tx1"/>
-                </a:solidFill>
-                <a:latin typeface="Calibri Light" panose="020F0302020204030204" pitchFamily="34" charset="0"/>
-                <a:ea typeface="Calibri Light" panose="020F0302020204030204" pitchFamily="34" charset="0"/>
-                <a:cs typeface="Calibri Light" panose="020F0302020204030204" pitchFamily="34" charset="0"/>
-              </a:rPr>
-              <a:t>학생이</a:t>
-            </a:r>
-            <a:r>
-              <a:rPr kumimoji="1" lang="en-US" altLang="ko-KR" sz="1400" dirty="0">
-                <a:solidFill>
-                  <a:schemeClr val="tx1"/>
-                </a:solidFill>
-                <a:latin typeface="Calibri Light" panose="020F0302020204030204" pitchFamily="34" charset="0"/>
-                <a:ea typeface="Calibri Light" panose="020F0302020204030204" pitchFamily="34" charset="0"/>
-                <a:cs typeface="Calibri Light" panose="020F0302020204030204" pitchFamily="34" charset="0"/>
-              </a:rPr>
-              <a:t>" → "</a:t>
-            </a:r>
-            <a:r>
-              <a:rPr kumimoji="1" lang="ko-KR" altLang="en-US" sz="1400" dirty="0">
-                <a:solidFill>
-                  <a:schemeClr val="tx1"/>
-                </a:solidFill>
-                <a:latin typeface="Calibri Light" panose="020F0302020204030204" pitchFamily="34" charset="0"/>
-                <a:ea typeface="Calibri Light" panose="020F0302020204030204" pitchFamily="34" charset="0"/>
-                <a:cs typeface="Calibri Light" panose="020F0302020204030204" pitchFamily="34" charset="0"/>
-              </a:rPr>
-              <a:t>학생</a:t>
-            </a:r>
-            <a:r>
-              <a:rPr kumimoji="1" lang="en-US" altLang="ko-KR" sz="1400" dirty="0">
-                <a:solidFill>
-                  <a:schemeClr val="tx1"/>
-                </a:solidFill>
-                <a:latin typeface="Calibri Light" panose="020F0302020204030204" pitchFamily="34" charset="0"/>
-                <a:ea typeface="Calibri Light" panose="020F0302020204030204" pitchFamily="34" charset="0"/>
-                <a:cs typeface="Calibri Light" panose="020F0302020204030204" pitchFamily="34" charset="0"/>
-              </a:rPr>
-              <a:t>" (L) + "</a:t>
-            </a:r>
-            <a:r>
-              <a:rPr kumimoji="1" lang="ko-KR" altLang="en-US" sz="1400" dirty="0">
-                <a:solidFill>
-                  <a:schemeClr val="tx1"/>
-                </a:solidFill>
-                <a:latin typeface="Calibri Light" panose="020F0302020204030204" pitchFamily="34" charset="0"/>
-                <a:ea typeface="Calibri Light" panose="020F0302020204030204" pitchFamily="34" charset="0"/>
-                <a:cs typeface="Calibri Light" panose="020F0302020204030204" pitchFamily="34" charset="0"/>
-              </a:rPr>
-              <a:t>이</a:t>
-            </a:r>
-            <a:r>
-              <a:rPr kumimoji="1" lang="en-US" altLang="ko-KR" sz="1400" dirty="0">
-                <a:solidFill>
-                  <a:schemeClr val="tx1"/>
-                </a:solidFill>
-                <a:latin typeface="Calibri Light" panose="020F0302020204030204" pitchFamily="34" charset="0"/>
-                <a:ea typeface="Calibri Light" panose="020F0302020204030204" pitchFamily="34" charset="0"/>
-                <a:cs typeface="Calibri Light" panose="020F0302020204030204" pitchFamily="34" charset="0"/>
-              </a:rPr>
-              <a:t>" (R)</a:t>
-            </a:r>
-            <a:endParaRPr kumimoji="1" lang="en-US" altLang="ja-JP" sz="1400" dirty="0">
-              <a:solidFill>
-                <a:schemeClr val="tx1"/>
-              </a:solidFill>
-              <a:latin typeface="Calibri Light" panose="020F0302020204030204" pitchFamily="34" charset="0"/>
-              <a:ea typeface="Calibri Light" panose="020F0302020204030204" pitchFamily="34" charset="0"/>
-              <a:cs typeface="Calibri Light" panose="020F0302020204030204" pitchFamily="34" charset="0"/>
-            </a:endParaRPr>
-          </a:p>
-        </p:txBody>
-      </p:sp>
-      <p:sp>
-        <p:nvSpPr>
-          <p:cNvPr id="20" name="TextBox 19"/>
-          <p:cNvSpPr txBox="1"/>
-          <p:nvPr/>
-        </p:nvSpPr>
-        <p:spPr>
-          <a:xfrm>
-            <a:off x="6315074" y="3731320"/>
-            <a:ext cx="3609975" cy="523220"/>
-          </a:xfrm>
-          <a:prstGeom prst="rect">
-            <a:avLst/>
-          </a:prstGeom>
-          <a:noFill/>
-        </p:spPr>
-        <p:txBody>
-          <a:bodyPr wrap="square" rtlCol="0">
-            <a:spAutoFit/>
-          </a:bodyPr>
-          <a:lstStyle/>
-          <a:p>
-            <a:r>
-              <a:rPr kumimoji="1" lang="en-US" altLang="ja-JP" sz="1400" b="1" dirty="0">
-                <a:solidFill>
-                  <a:srgbClr val="FF0000"/>
-                </a:solidFill>
-                <a:latin typeface="Calibri Light" panose="020F0302020204030204" pitchFamily="34" charset="0"/>
-                <a:ea typeface="Calibri Light" panose="020F0302020204030204" pitchFamily="34" charset="0"/>
-                <a:cs typeface="Calibri Light" panose="020F0302020204030204" pitchFamily="34" charset="0"/>
-              </a:rPr>
-              <a:t>Notes:</a:t>
-            </a:r>
-            <a:endParaRPr kumimoji="1" lang="en-US" altLang="ja-JP" sz="1400" b="1" dirty="0">
-              <a:solidFill>
-                <a:srgbClr val="FF0000"/>
-              </a:solidFill>
-              <a:latin typeface="Calibri Light" panose="020F0302020204030204" pitchFamily="34" charset="0"/>
-              <a:ea typeface="Calibri Light" panose="020F0302020204030204" pitchFamily="34" charset="0"/>
-              <a:cs typeface="Calibri Light" panose="020F0302020204030204" pitchFamily="34" charset="0"/>
-            </a:endParaRPr>
-          </a:p>
-          <a:p>
-            <a:pPr marL="285750" indent="-285750">
-              <a:buFont typeface="Arial" panose="020B0604020202090204" pitchFamily="34" charset="0"/>
-              <a:buChar char="•"/>
-            </a:pPr>
+                <a:latin typeface="Calibri Light" panose="020F0302020204030204" pitchFamily="34" charset="0"/>
+                <a:ea typeface="Calibri Light" panose="020F0302020204030204" pitchFamily="34" charset="0"/>
+                <a:cs typeface="Calibri Light" panose="020F0302020204030204" pitchFamily="34" charset="0"/>
+              </a:rPr>
+              <a:t>Possible to use </a:t>
+            </a:r>
+            <a:r>
+              <a:rPr lang="en-US" altLang="ja-JP" sz="1400" dirty="0" err="1">
+                <a:latin typeface="Calibri Light" panose="020F0302020204030204" pitchFamily="34" charset="0"/>
+                <a:ea typeface="Calibri Light" panose="020F0302020204030204" pitchFamily="34" charset="0"/>
+                <a:cs typeface="Calibri Light" panose="020F0302020204030204" pitchFamily="34" charset="0"/>
+                <a:hlinkClick r:id="rId4"/>
+              </a:rPr>
+              <a:t>spaCy</a:t>
+            </a:r>
             <a:r>
               <a:rPr lang="en-US" altLang="ja-JP" sz="1400" dirty="0">
                 <a:latin typeface="Calibri Light" panose="020F0302020204030204" pitchFamily="34" charset="0"/>
                 <a:ea typeface="Calibri Light" panose="020F0302020204030204" pitchFamily="34" charset="0"/>
                 <a:cs typeface="Calibri Light" panose="020F0302020204030204" pitchFamily="34" charset="0"/>
               </a:rPr>
-              <a:t>Possible to use </a:t>
-            </a:r>
-            <a:r>
-              <a:rPr lang="en-US" altLang="ja-JP" sz="1400" dirty="0" err="1">
-                <a:latin typeface="Calibri Light" panose="020F0302020204030204" pitchFamily="34" charset="0"/>
-                <a:ea typeface="Calibri Light" panose="020F0302020204030204" pitchFamily="34" charset="0"/>
-                <a:cs typeface="Calibri Light" panose="020F0302020204030204" pitchFamily="34" charset="0"/>
-                <a:hlinkClick r:id="rId3"/>
-              </a:rPr>
-              <a:t>spaCy</a:t>
-            </a:r>
-            <a:r>
-              <a:rPr lang="en-US" altLang="ja-JP" sz="1400" dirty="0">
-                <a:latin typeface="Calibri Light" panose="020F0302020204030204" pitchFamily="34" charset="0"/>
-                <a:ea typeface="Calibri Light" panose="020F0302020204030204" pitchFamily="34" charset="0"/>
-                <a:cs typeface="Calibri Light" panose="020F0302020204030204" pitchFamily="34" charset="0"/>
-              </a:rPr>
               <a:t> for English &amp; Korean</a:t>
             </a:r>
-            <a:endParaRPr lang="en-US" altLang="ja-JP" sz="1400" dirty="0">
-              <a:latin typeface="Calibri Light" panose="020F0302020204030204" pitchFamily="34" charset="0"/>
-              <a:ea typeface="Calibri Light" panose="020F0302020204030204" pitchFamily="34" charset="0"/>
-              <a:cs typeface="Calibri Light" panose="020F0302020204030204" pitchFamily="34" charset="0"/>
-            </a:endParaRPr>
           </a:p>
         </p:txBody>
       </p:sp>
@@ -7907,14 +7804,6 @@
               </a:rPr>
               <a:t>.vocab file</a:t>
             </a:r>
-            <a:endParaRPr kumimoji="1" lang="en-US" altLang="ja-JP" b="1" dirty="0" err="1">
-              <a:solidFill>
-                <a:srgbClr val="FF0000"/>
-              </a:solidFill>
-              <a:latin typeface="Calibri Light" panose="020F0302020204030204" pitchFamily="34" charset="0"/>
-              <a:ea typeface="Calibri Light" panose="020F0302020204030204" pitchFamily="34" charset="0"/>
-              <a:cs typeface="Calibri Light" panose="020F0302020204030204" pitchFamily="34" charset="0"/>
-            </a:endParaRPr>
           </a:p>
         </p:txBody>
       </p:sp>
@@ -7927,7 +7816,7 @@
           <p:nvPr/>
         </p:nvPicPr>
         <p:blipFill>
-          <a:blip r:embed="rId1"/>
+          <a:blip r:embed="rId2"/>
           <a:stretch>
             <a:fillRect/>
           </a:stretch>
@@ -7962,6 +7851,7 @@
           <a:bodyPr wrap="square" rtlCol="0">
             <a:spAutoFit/>
           </a:bodyPr>
+          <a:lstStyle/>
           <a:p>
             <a:r>
               <a:rPr lang="en-US" b="1">
@@ -7970,10 +7860,6 @@
               </a:rPr>
               <a:t>token</a:t>
             </a:r>
-            <a:endParaRPr lang="en-US" b="1">
-              <a:latin typeface="Calibri Light" panose="020F0302020204030204" pitchFamily="34" charset="0"/>
-              <a:cs typeface="Calibri Light" panose="020F0302020204030204" pitchFamily="34" charset="0"/>
-            </a:endParaRPr>
           </a:p>
         </p:txBody>
       </p:sp>
@@ -7997,6 +7883,7 @@
           <a:bodyPr wrap="square" rtlCol="0">
             <a:spAutoFit/>
           </a:bodyPr>
+          <a:lstStyle/>
           <a:p>
             <a:r>
               <a:rPr lang="en-US" b="1">
@@ -8005,10 +7892,6 @@
               </a:rPr>
               <a:t>score</a:t>
             </a:r>
-            <a:endParaRPr lang="en-US" b="1">
-              <a:latin typeface="Calibri Light" panose="020F0302020204030204" pitchFamily="34" charset="0"/>
-              <a:cs typeface="Calibri Light" panose="020F0302020204030204" pitchFamily="34" charset="0"/>
-            </a:endParaRPr>
           </a:p>
         </p:txBody>
       </p:sp>
@@ -8055,6 +7938,7 @@
         </p:style>
         <p:txBody>
           <a:bodyPr rtlCol="0" anchor="ctr"/>
+          <a:lstStyle/>
           <a:p>
             <a:pPr algn="ctr"/>
             <a:r>
@@ -8067,13 +7951,6 @@
               </a:rPr>
               <a:t>start of sequence</a:t>
             </a:r>
-            <a:endParaRPr lang="en-US">
-              <a:solidFill>
-                <a:schemeClr val="tx1"/>
-              </a:solidFill>
-              <a:latin typeface="Calibri Light" panose="020F0302020204030204" pitchFamily="34" charset="0"/>
-              <a:cs typeface="Calibri Light" panose="020F0302020204030204" pitchFamily="34" charset="0"/>
-            </a:endParaRPr>
           </a:p>
         </p:txBody>
       </p:sp>
@@ -8120,6 +7997,7 @@
         </p:style>
         <p:txBody>
           <a:bodyPr rtlCol="0" anchor="ctr"/>
+          <a:lstStyle/>
           <a:p>
             <a:pPr algn="ctr"/>
             <a:r>
@@ -8132,13 +8010,6 @@
               </a:rPr>
               <a:t>end of sequence</a:t>
             </a:r>
-            <a:endParaRPr lang="en-US">
-              <a:solidFill>
-                <a:schemeClr val="tx1"/>
-              </a:solidFill>
-              <a:latin typeface="Calibri Light" panose="020F0302020204030204" pitchFamily="34" charset="0"/>
-              <a:cs typeface="Calibri Light" panose="020F0302020204030204" pitchFamily="34" charset="0"/>
-            </a:endParaRPr>
           </a:p>
         </p:txBody>
       </p:sp>
@@ -8161,6 +8032,7 @@
           <a:bodyPr wrap="square">
             <a:spAutoFit/>
           </a:bodyPr>
+          <a:lstStyle/>
           <a:p>
             <a:r>
               <a:rPr lang="en-US" altLang="ja-JP" sz="1600">
@@ -8169,10 +8041,6 @@
               </a:rPr>
               <a:t>Higher values (less negative) = more common in the training data</a:t>
             </a:r>
-            <a:endParaRPr lang="en-US" altLang="ja-JP" sz="1600">
-              <a:latin typeface="Calibri Light" panose="020F0302020204030204" pitchFamily="34" charset="0"/>
-              <a:cs typeface="Calibri Light" panose="020F0302020204030204" pitchFamily="34" charset="0"/>
-            </a:endParaRPr>
           </a:p>
         </p:txBody>
       </p:sp>
@@ -8185,7 +8053,7 @@
           <p:nvPr/>
         </p:nvPicPr>
         <p:blipFill>
-          <a:blip r:embed="rId2"/>
+          <a:blip r:embed="rId3"/>
           <a:stretch>
             <a:fillRect/>
           </a:stretch>
@@ -8219,6 +8087,7 @@
           <a:bodyPr wrap="square">
             <a:spAutoFit/>
           </a:bodyPr>
+          <a:lstStyle/>
           <a:p>
             <a:r>
               <a:rPr lang="en-US" altLang="ja-JP" sz="1600">
@@ -8227,10 +8096,6 @@
               </a:rPr>
               <a:t>sentencepiece has better morphological understanding:</a:t>
             </a:r>
-            <a:endParaRPr lang="en-US" altLang="ja-JP" sz="1600">
-              <a:latin typeface="Calibri Light" panose="020F0302020204030204" pitchFamily="34" charset="0"/>
-              <a:cs typeface="Calibri Light" panose="020F0302020204030204" pitchFamily="34" charset="0"/>
-            </a:endParaRPr>
           </a:p>
           <a:p>
             <a:pPr marL="285750" indent="-285750">
@@ -8244,10 +8109,6 @@
               </a:rPr>
               <a:t>E.g. “obviously” is tokenized into “obvious” + suffix “ly”</a:t>
             </a:r>
-            <a:endParaRPr lang="en-US" altLang="ja-JP" sz="1600">
-              <a:latin typeface="Calibri Light" panose="020F0302020204030204" pitchFamily="34" charset="0"/>
-              <a:cs typeface="Calibri Light" panose="020F0302020204030204" pitchFamily="34" charset="0"/>
-            </a:endParaRPr>
           </a:p>
         </p:txBody>
       </p:sp>
@@ -8333,6 +8194,7 @@
           <a:bodyPr wrap="square" rtlCol="0">
             <a:spAutoFit/>
           </a:bodyPr>
+          <a:lstStyle/>
           <a:p>
             <a:r>
               <a:rPr lang="en-US" b="1">
@@ -8341,10 +8203,6 @@
               </a:rPr>
               <a:t>Encoder:</a:t>
             </a:r>
-            <a:endParaRPr lang="en-US" b="1">
-              <a:latin typeface="Calibri Light" panose="020F0302020204030204" pitchFamily="34" charset="0"/>
-              <a:cs typeface="Calibri Light" panose="020F0302020204030204" pitchFamily="34" charset="0"/>
-            </a:endParaRPr>
           </a:p>
           <a:p>
             <a:pPr marL="342900" indent="-342900">
@@ -8366,10 +8224,6 @@
               </a:rPr>
               <a:t>After applying ReLU  </a:t>
             </a:r>
-            <a:endParaRPr lang="en-US">
-              <a:latin typeface="Calibri Light" panose="020F0302020204030204" pitchFamily="34" charset="0"/>
-              <a:cs typeface="Calibri Light" panose="020F0302020204030204" pitchFamily="34" charset="0"/>
-            </a:endParaRPr>
           </a:p>
           <a:p>
             <a:pPr marL="342900" indent="-342900">
@@ -8383,10 +8237,6 @@
               </a:rPr>
               <a:t>Multi-head Attention: After applying softmax</a:t>
             </a:r>
-            <a:endParaRPr lang="en-US">
-              <a:latin typeface="Calibri Light" panose="020F0302020204030204" pitchFamily="34" charset="0"/>
-              <a:cs typeface="Calibri Light" panose="020F0302020204030204" pitchFamily="34" charset="0"/>
-            </a:endParaRPr>
           </a:p>
           <a:p>
             <a:pPr marL="342900" indent="-342900">
@@ -8400,10 +8250,6 @@
               </a:rPr>
               <a:t>After applying the attention block</a:t>
             </a:r>
-            <a:endParaRPr lang="en-US">
-              <a:latin typeface="Calibri Light" panose="020F0302020204030204" pitchFamily="34" charset="0"/>
-              <a:cs typeface="Calibri Light" panose="020F0302020204030204" pitchFamily="34" charset="0"/>
-            </a:endParaRPr>
           </a:p>
           <a:p>
             <a:pPr marL="342900" indent="-342900">
@@ -8417,10 +8263,6 @@
               </a:rPr>
               <a:t>After applying the feed-forward block</a:t>
             </a:r>
-            <a:endParaRPr lang="en-US">
-              <a:latin typeface="Calibri Light" panose="020F0302020204030204" pitchFamily="34" charset="0"/>
-              <a:cs typeface="Calibri Light" panose="020F0302020204030204" pitchFamily="34" charset="0"/>
-            </a:endParaRPr>
           </a:p>
           <a:p>
             <a:pPr marL="342900" indent="-342900">
@@ -8434,10 +8276,6 @@
               </a:rPr>
               <a:t>After Positional Encoding</a:t>
             </a:r>
-            <a:endParaRPr lang="en-US">
-              <a:latin typeface="Calibri Light" panose="020F0302020204030204" pitchFamily="34" charset="0"/>
-              <a:cs typeface="Calibri Light" panose="020F0302020204030204" pitchFamily="34" charset="0"/>
-            </a:endParaRPr>
           </a:p>
         </p:txBody>
       </p:sp>
@@ -8450,7 +8288,7 @@
           <p:nvPr/>
         </p:nvPicPr>
         <p:blipFill>
-          <a:blip r:embed="rId1"/>
+          <a:blip r:embed="rId2"/>
           <a:stretch>
             <a:fillRect/>
           </a:stretch>
@@ -8474,7 +8312,7 @@
           <p:nvPr/>
         </p:nvPicPr>
         <p:blipFill>
-          <a:blip r:embed="rId2"/>
+          <a:blip r:embed="rId3"/>
           <a:stretch>
             <a:fillRect/>
           </a:stretch>
@@ -8498,7 +8336,7 @@
           <p:nvPr/>
         </p:nvPicPr>
         <p:blipFill>
-          <a:blip r:embed="rId3"/>
+          <a:blip r:embed="rId4"/>
           <a:stretch>
             <a:fillRect/>
           </a:stretch>
@@ -8552,6 +8390,7 @@
         </p:style>
         <p:txBody>
           <a:bodyPr rtlCol="0" anchor="ctr"/>
+          <a:lstStyle/>
           <a:p>
             <a:pPr algn="ctr"/>
             <a:endParaRPr kumimoji="1" lang="ja-JP" altLang="en-US" sz="1400">
@@ -8604,6 +8443,7 @@
         </p:style>
         <p:txBody>
           <a:bodyPr rtlCol="0" anchor="ctr"/>
+          <a:lstStyle/>
           <a:p>
             <a:pPr algn="ctr"/>
             <a:r>
@@ -8667,6 +8507,7 @@
         </p:style>
         <p:txBody>
           <a:bodyPr rtlCol="0" anchor="ctr"/>
+          <a:lstStyle/>
           <a:p>
             <a:pPr algn="ctr"/>
             <a:endParaRPr kumimoji="1" lang="ja-JP" altLang="en-US" sz="1400">
@@ -8719,6 +8560,7 @@
         </p:style>
         <p:txBody>
           <a:bodyPr rtlCol="0" anchor="ctr"/>
+          <a:lstStyle/>
           <a:p>
             <a:pPr algn="ctr"/>
             <a:r>
@@ -8782,6 +8624,7 @@
         </p:style>
         <p:txBody>
           <a:bodyPr rtlCol="0" anchor="ctr"/>
+          <a:lstStyle/>
           <a:p>
             <a:pPr algn="ctr"/>
             <a:endParaRPr kumimoji="1" lang="ja-JP" altLang="en-US" sz="1400">
@@ -8830,6 +8673,7 @@
         </p:style>
         <p:txBody>
           <a:bodyPr rtlCol="0" anchor="ctr"/>
+          <a:lstStyle/>
           <a:p>
             <a:pPr algn="ctr"/>
             <a:endParaRPr kumimoji="1" lang="ja-JP" altLang="en-US" sz="1400">
@@ -8882,6 +8726,7 @@
         </p:style>
         <p:txBody>
           <a:bodyPr rtlCol="0" anchor="ctr"/>
+          <a:lstStyle/>
           <a:p>
             <a:pPr algn="ctr"/>
             <a:r>
@@ -8949,6 +8794,7 @@
         </p:style>
         <p:txBody>
           <a:bodyPr rtlCol="0" anchor="ctr"/>
+          <a:lstStyle/>
           <a:p>
             <a:pPr algn="ctr"/>
             <a:r>
@@ -8982,7 +8828,7 @@
           <p:nvPr/>
         </p:nvPicPr>
         <p:blipFill>
-          <a:blip r:embed="rId4"/>
+          <a:blip r:embed="rId5"/>
           <a:stretch>
             <a:fillRect/>
           </a:stretch>
@@ -9036,6 +8882,7 @@
         </p:style>
         <p:txBody>
           <a:bodyPr rtlCol="0" anchor="ctr"/>
+          <a:lstStyle/>
           <a:p>
             <a:pPr algn="ctr"/>
             <a:endParaRPr kumimoji="1" lang="ja-JP" altLang="en-US" sz="1400">
@@ -9088,6 +8935,7 @@
         </p:style>
         <p:txBody>
           <a:bodyPr rtlCol="0" anchor="ctr"/>
+          <a:lstStyle/>
           <a:p>
             <a:pPr algn="ctr"/>
             <a:r>
@@ -9167,11 +9015,6 @@
               </a:rPr>
               <a:t>Beam Search (01/11/2025)</a:t>
             </a:r>
-            <a:endParaRPr kumimoji="1" lang="en-US" altLang="ja-JP" sz="2400" b="1" dirty="0">
-              <a:latin typeface="Calibri" panose="020F0502020204030204" charset="0"/>
-              <a:ea typeface="Calibri Light" panose="020F0302020204030204" pitchFamily="34" charset="0"/>
-              <a:cs typeface="Calibri" panose="020F0502020204030204" charset="0"/>
-            </a:endParaRPr>
           </a:p>
         </p:txBody>
       </p:sp>
@@ -9195,6 +9038,7 @@
           <a:bodyPr wrap="square" rtlCol="0" anchor="t">
             <a:noAutofit/>
           </a:bodyPr>
+          <a:lstStyle/>
           <a:p>
             <a:pPr marL="285750" indent="-285750">
               <a:buFont typeface="Arial" panose="020B0604020202090204" pitchFamily="34" charset="0"/>
@@ -9207,10 +9051,6 @@
               </a:rPr>
               <a:t>Beam Search can be used to enhance the meaning of the sentence as a whole. Instead of picking words with highest probability at each timestep</a:t>
             </a:r>
-            <a:endParaRPr lang="en-US" altLang="en-US">
-              <a:latin typeface="Calibri" panose="020F0502020204030204" charset="0"/>
-              <a:cs typeface="Calibri" panose="020F0502020204030204" charset="0"/>
-            </a:endParaRPr>
           </a:p>
           <a:p>
             <a:pPr marL="285750" indent="-285750">
@@ -9244,6 +9084,7 @@
           <a:bodyPr wrap="square" rtlCol="0" anchor="t">
             <a:noAutofit/>
           </a:bodyPr>
+          <a:lstStyle/>
           <a:p>
             <a:pPr marL="285750" indent="-285750">
               <a:buFont typeface="Arial" panose="020B0604020202090204" pitchFamily="34" charset="0"/>
@@ -9256,10 +9097,6 @@
               </a:rPr>
               <a:t>A week before, I discovered that accuracy is not a useful metric for seq2seq models as words can be synonyms -&gt; cannot represent the reference with 100% ‘happy’ can also be translated as ‘joyful’ yet those two words have different tokens </a:t>
             </a:r>
-            <a:endParaRPr lang="en-US" altLang="en-US">
-              <a:latin typeface="Calibri" panose="020F0502020204030204" charset="0"/>
-              <a:cs typeface="Calibri" panose="020F0502020204030204" charset="0"/>
-            </a:endParaRPr>
           </a:p>
           <a:p>
             <a:r>
@@ -9269,10 +9106,6 @@
               </a:rPr>
               <a:t>-&gt; Use BLEU to evaluate model’s performance</a:t>
             </a:r>
-            <a:endParaRPr lang="en-US">
-              <a:latin typeface="Calibri" panose="020F0502020204030204" charset="0"/>
-              <a:cs typeface="Calibri" panose="020F0502020204030204" charset="0"/>
-            </a:endParaRPr>
           </a:p>
         </p:txBody>
       </p:sp>
@@ -9296,6 +9129,7 @@
           <a:bodyPr wrap="square" rtlCol="0">
             <a:spAutoFit/>
           </a:bodyPr>
+          <a:lstStyle/>
           <a:p>
             <a:pPr marL="285750" indent="-285750">
               <a:buFont typeface="Arial" panose="020B0604020202090204" pitchFamily="34" charset="0"/>
@@ -9493,12 +9327,6 @@
               </a:rPr>
               <a:t>positions into the model.</a:t>
             </a:r>
-            <a:endParaRPr lang="en-US" altLang="ja-JP" sz="1400" dirty="0">
-              <a:latin typeface="Calibri Light" panose="020F0302020204030204" pitchFamily="34" charset="0"/>
-              <a:ea typeface="Calibri Light" panose="020F0302020204030204" pitchFamily="34" charset="0"/>
-              <a:cs typeface="Calibri Light" panose="020F0302020204030204" pitchFamily="34" charset="0"/>
-              <a:sym typeface="Wingdings" panose="05000000000000000000" pitchFamily="2" charset="2"/>
-            </a:endParaRPr>
           </a:p>
           <a:p>
             <a:pPr marL="285750" indent="-285750">
@@ -9532,12 +9360,6 @@
               </a:rPr>
               <a:t> is created for each token</a:t>
             </a:r>
-            <a:endParaRPr lang="en-US" altLang="ja-JP" sz="1400" dirty="0">
-              <a:latin typeface="Calibri Light" panose="020F0302020204030204" pitchFamily="34" charset="0"/>
-              <a:ea typeface="Calibri Light" panose="020F0302020204030204" pitchFamily="34" charset="0"/>
-              <a:cs typeface="Calibri Light" panose="020F0302020204030204" pitchFamily="34" charset="0"/>
-              <a:sym typeface="Wingdings" panose="05000000000000000000" pitchFamily="2" charset="2"/>
-            </a:endParaRPr>
           </a:p>
         </p:txBody>
       </p:sp>
@@ -9568,7 +9390,7 @@
                 <a:latin typeface="Calibri Light" panose="020F0302020204030204" pitchFamily="34" charset="0"/>
                 <a:ea typeface="Calibri Light" panose="020F0302020204030204" pitchFamily="34" charset="0"/>
                 <a:cs typeface="Calibri Light" panose="020F0302020204030204" pitchFamily="34" charset="0"/>
-                <a:hlinkClick r:id="rId1"/>
+                <a:hlinkClick r:id="rId2"/>
               </a:rPr>
               <a:t>Refs</a:t>
             </a:r>
@@ -9588,7 +9410,7 @@
           <p:nvPr/>
         </p:nvPicPr>
         <p:blipFill>
-          <a:blip r:embed="rId2"/>
+          <a:blip r:embed="rId3"/>
           <a:stretch>
             <a:fillRect/>
           </a:stretch>
@@ -9772,7 +9594,7 @@
           <p:nvPr/>
         </p:nvPicPr>
         <p:blipFill>
-          <a:blip r:embed="rId3"/>
+          <a:blip r:embed="rId4"/>
           <a:stretch>
             <a:fillRect/>
           </a:stretch>
@@ -9876,7 +9698,7 @@
           <p:nvPr/>
         </p:nvPicPr>
         <p:blipFill>
-          <a:blip r:embed="rId4"/>
+          <a:blip r:embed="rId5"/>
           <a:stretch>
             <a:fillRect/>
           </a:stretch>
@@ -9993,7 +9815,6 @@
               <a:rPr lang="ja-JP" altLang="en-US" sz="1200" dirty="0"/>
               <a:t>https://github.com/SamLynnEvans/Transformer/blob/master/Embed.py</a:t>
             </a:r>
-            <a:endParaRPr lang="ja-JP" altLang="en-US" sz="1200" dirty="0"/>
           </a:p>
         </p:txBody>
       </p:sp>
@@ -10069,7 +9890,7 @@
           <p:nvPr/>
         </p:nvPicPr>
         <p:blipFill>
-          <a:blip r:embed="rId1">
+          <a:blip r:embed="rId2" cstate="print">
             <a:extLst>
               <a:ext uri="{28A0092B-C50C-407E-A947-70E740481C1C}">
                 <a14:useLocalDpi xmlns:a14="http://schemas.microsoft.com/office/drawing/2010/main" val="0"/>
@@ -10168,6 +9989,8 @@
               </a:rPr>
               <a:t>E.g. Consider two sentences:</a:t>
             </a:r>
+          </a:p>
+          <a:p>
             <a:endParaRPr lang="en-US" altLang="ja-JP" sz="1400" dirty="0">
               <a:latin typeface="Calibri Light" panose="020F0302020204030204" pitchFamily="34" charset="0"/>
               <a:ea typeface="Calibri Light" panose="020F0302020204030204" pitchFamily="34" charset="0"/>
@@ -10175,13 +9998,6 @@
             </a:endParaRPr>
           </a:p>
           <a:p>
-            <a:endParaRPr lang="en-US" altLang="ja-JP" sz="1400" dirty="0">
-              <a:latin typeface="Calibri Light" panose="020F0302020204030204" pitchFamily="34" charset="0"/>
-              <a:ea typeface="Calibri Light" panose="020F0302020204030204" pitchFamily="34" charset="0"/>
-              <a:cs typeface="Calibri Light" panose="020F0302020204030204" pitchFamily="34" charset="0"/>
-            </a:endParaRPr>
-          </a:p>
-          <a:p>
             <a:pPr marL="285750" indent="-285750">
               <a:buFont typeface="Arial" panose="020B0604020202090204" pitchFamily="34" charset="0"/>
               <a:buChar char="•"/>
@@ -10232,11 +10048,6 @@
               </a:rPr>
               <a:t> was hungry.</a:t>
             </a:r>
-            <a:endParaRPr lang="en-US" altLang="ja-JP" sz="1400" dirty="0">
-              <a:latin typeface="Calibri Light" panose="020F0302020204030204" pitchFamily="34" charset="0"/>
-              <a:ea typeface="Calibri Light" panose="020F0302020204030204" pitchFamily="34" charset="0"/>
-              <a:cs typeface="Calibri Light" panose="020F0302020204030204" pitchFamily="34" charset="0"/>
-            </a:endParaRPr>
           </a:p>
           <a:p>
             <a:pPr marL="285750" indent="-285750">
@@ -10397,7 +10208,7 @@
           <p:nvPr/>
         </p:nvPicPr>
         <p:blipFill>
-          <a:blip r:embed="rId2">
+          <a:blip r:embed="rId3">
             <a:extLst>
               <a:ext uri="{28A0092B-C50C-407E-A947-70E740481C1C}">
                 <a14:useLocalDpi xmlns:a14="http://schemas.microsoft.com/office/drawing/2010/main" val="0"/>
@@ -10456,7 +10267,7 @@
                 <a:latin typeface="Calibri Light" panose="020F0302020204030204" pitchFamily="34" charset="0"/>
                 <a:ea typeface="Calibri Light" panose="020F0302020204030204" pitchFamily="34" charset="0"/>
                 <a:cs typeface="Calibri Light" panose="020F0302020204030204" pitchFamily="34" charset="0"/>
-                <a:hlinkClick r:id="rId3"/>
+                <a:hlinkClick r:id="rId4"/>
               </a:rPr>
               <a:t>Refs</a:t>
             </a:r>
@@ -10476,7 +10287,7 @@
           <p:nvPr/>
         </p:nvPicPr>
         <p:blipFill>
-          <a:blip r:embed="rId4"/>
+          <a:blip r:embed="rId5"/>
           <a:srcRect t="16034"/>
           <a:stretch>
             <a:fillRect/>
@@ -10522,11 +10333,6 @@
               </a:rPr>
               <a:t>(2) Finding the weights:</a:t>
             </a:r>
-            <a:endParaRPr kumimoji="1" lang="en-US" altLang="ja-JP" sz="1400" b="1" dirty="0">
-              <a:latin typeface="Calibri Light" panose="020F0302020204030204" pitchFamily="34" charset="0"/>
-              <a:ea typeface="Calibri Light" panose="020F0302020204030204" pitchFamily="34" charset="0"/>
-              <a:cs typeface="Calibri Light" panose="020F0302020204030204" pitchFamily="34" charset="0"/>
-            </a:endParaRPr>
           </a:p>
           <a:p>
             <a:r>
@@ -10598,12 +10404,6 @@
               </a:rPr>
               <a:t> token</a:t>
             </a:r>
-            <a:endParaRPr kumimoji="1" lang="en-US" altLang="ja-JP" sz="1400" dirty="0">
-              <a:latin typeface="Calibri Light" panose="020F0302020204030204" pitchFamily="34" charset="0"/>
-              <a:ea typeface="Calibri Light" panose="020F0302020204030204" pitchFamily="34" charset="0"/>
-              <a:cs typeface="Calibri Light" panose="020F0302020204030204" pitchFamily="34" charset="0"/>
-              <a:sym typeface="Wingdings" panose="05000000000000000000" pitchFamily="2" charset="2"/>
-            </a:endParaRPr>
           </a:p>
           <a:p>
             <a:r>
@@ -10713,7 +10513,7 @@
           <p:nvPr/>
         </p:nvPicPr>
         <p:blipFill>
-          <a:blip r:embed="rId5"/>
+          <a:blip r:embed="rId6"/>
           <a:srcRect l="6918" r="15445"/>
           <a:stretch>
             <a:fillRect/>
@@ -10759,11 +10559,6 @@
               </a:rPr>
               <a:t>If two vectors point in </a:t>
             </a:r>
-            <a:endParaRPr lang="en-US" altLang="ja-JP" sz="1400" dirty="0">
-              <a:latin typeface="Calibri Light" panose="020F0302020204030204" pitchFamily="34" charset="0"/>
-              <a:ea typeface="Calibri Light" panose="020F0302020204030204" pitchFamily="34" charset="0"/>
-              <a:cs typeface="Calibri Light" panose="020F0302020204030204" pitchFamily="34" charset="0"/>
-            </a:endParaRPr>
           </a:p>
           <a:p>
             <a:pPr marL="342900" indent="-342900">
@@ -10827,11 +10622,6 @@
               </a:rPr>
               <a:t>. </a:t>
             </a:r>
-            <a:endParaRPr lang="en-US" altLang="ja-JP" sz="1400" dirty="0">
-              <a:latin typeface="Calibri Light" panose="020F0302020204030204" pitchFamily="34" charset="0"/>
-              <a:ea typeface="Calibri Light" panose="020F0302020204030204" pitchFamily="34" charset="0"/>
-              <a:cs typeface="Calibri Light" panose="020F0302020204030204" pitchFamily="34" charset="0"/>
-            </a:endParaRPr>
           </a:p>
           <a:p>
             <a:pPr marL="342900" indent="-342900">
@@ -10862,11 +10652,6 @@
               </a:rPr>
               <a:t>zero.</a:t>
             </a:r>
-            <a:endParaRPr lang="en-US" altLang="ja-JP" sz="1400" b="1" dirty="0">
-              <a:latin typeface="Calibri Light" panose="020F0302020204030204" pitchFamily="34" charset="0"/>
-              <a:ea typeface="Calibri Light" panose="020F0302020204030204" pitchFamily="34" charset="0"/>
-              <a:cs typeface="Calibri Light" panose="020F0302020204030204" pitchFamily="34" charset="0"/>
-            </a:endParaRPr>
           </a:p>
           <a:p>
             <a:pPr marL="342900" indent="-342900">
@@ -11089,11 +10874,6 @@
               </a:rPr>
               <a:t>|</a:t>
             </a:r>
-            <a:endParaRPr kumimoji="1" lang="en-US" altLang="ja-JP" sz="1400" dirty="0">
-              <a:latin typeface="Calibri Light" panose="020F0302020204030204" pitchFamily="34" charset="0"/>
-              <a:ea typeface="Calibri Light" panose="020F0302020204030204" pitchFamily="34" charset="0"/>
-              <a:cs typeface="Calibri Light" panose="020F0302020204030204" pitchFamily="34" charset="0"/>
-            </a:endParaRPr>
           </a:p>
           <a:p>
             <a:r>
@@ -11176,7 +10956,7 @@
           <p:nvPr/>
         </p:nvPicPr>
         <p:blipFill>
-          <a:blip r:embed="rId6"/>
+          <a:blip r:embed="rId7"/>
           <a:srcRect t="14568"/>
           <a:stretch>
             <a:fillRect/>
@@ -11419,7 +11199,7 @@
           <p:nvPr/>
         </p:nvPicPr>
         <p:blipFill>
-          <a:blip r:embed="rId1">
+          <a:blip r:embed="rId3">
             <a:extLst>
               <a:ext uri="{28A0092B-C50C-407E-A947-70E740481C1C}">
                 <a14:useLocalDpi xmlns:a14="http://schemas.microsoft.com/office/drawing/2010/main" val="0"/>
@@ -11560,7 +11340,7 @@
           <p:nvPr/>
         </p:nvPicPr>
         <p:blipFill>
-          <a:blip r:embed="rId2">
+          <a:blip r:embed="rId4">
             <a:extLst>
               <a:ext uri="{28A0092B-C50C-407E-A947-70E740481C1C}">
                 <a14:useLocalDpi xmlns:a14="http://schemas.microsoft.com/office/drawing/2010/main" val="0"/>
@@ -11755,7 +11535,6 @@
               <a:rPr lang="en-US" altLang="ja-JP" sz="1400" dirty="0"/>
               <a:t> (Key matrix) of shape k x k. </a:t>
             </a:r>
-            <a:endParaRPr lang="en-US" altLang="ja-JP" sz="1400" dirty="0"/>
           </a:p>
           <a:p>
             <a:pPr marL="285750" indent="-285750">
@@ -11774,7 +11553,6 @@
               <a:rPr lang="en-US" altLang="ja-JP" sz="1400" dirty="0"/>
               <a:t>(Query matrix) of shape k x k. (? – My deduction) </a:t>
             </a:r>
-            <a:endParaRPr lang="en-US" altLang="ja-JP" sz="1400" dirty="0"/>
           </a:p>
           <a:p>
             <a:pPr marL="285750" indent="-285750">
@@ -11924,7 +11702,7 @@
           <p:nvPr/>
         </p:nvPicPr>
         <p:blipFill rotWithShape="1">
-          <a:blip r:embed="rId1">
+          <a:blip r:embed="rId3">
             <a:extLst>
               <a:ext uri="{28A0092B-C50C-407E-A947-70E740481C1C}">
                 <a14:useLocalDpi xmlns:a14="http://schemas.microsoft.com/office/drawing/2010/main" val="0"/>
@@ -12034,13 +11812,6 @@
               </a:rPr>
               <a:t>(1) Score calculations:</a:t>
             </a:r>
-            <a:endParaRPr lang="en-US" altLang="ja-JP" sz="1600" b="1" dirty="0">
-              <a:solidFill>
-                <a:schemeClr val="accent1"/>
-              </a:solidFill>
-              <a:latin typeface="Calibri Light" panose="020F0302020204030204" pitchFamily="34" charset="0"/>
-              <a:cs typeface="Calibri Light" panose="020F0302020204030204" pitchFamily="34" charset="0"/>
-            </a:endParaRPr>
           </a:p>
           <a:p>
             <a:pPr marL="285750" indent="-285750">
@@ -12104,11 +11875,6 @@
               </a:rPr>
               <a:t>)</a:t>
             </a:r>
-            <a:endParaRPr lang="en-US" altLang="ja-JP" sz="1600" dirty="0">
-              <a:latin typeface="Calibri Light" panose="020F0302020204030204" pitchFamily="34" charset="0"/>
-              <a:ea typeface="Calibri Light" panose="020F0302020204030204" pitchFamily="34" charset="0"/>
-              <a:cs typeface="Calibri Light" panose="020F0302020204030204" pitchFamily="34" charset="0"/>
-            </a:endParaRPr>
           </a:p>
           <a:p>
             <a:endParaRPr lang="en-US" altLang="ja-JP" sz="1600" dirty="0">
@@ -12231,13 +11997,6 @@
               </a:rPr>
               <a:t> function):</a:t>
             </a:r>
-            <a:endParaRPr lang="en-US" altLang="ja-JP" sz="1600" b="1" dirty="0">
-              <a:solidFill>
-                <a:srgbClr val="FF0000"/>
-              </a:solidFill>
-              <a:latin typeface="Calibri Light" panose="020F0302020204030204" pitchFamily="34" charset="0"/>
-              <a:cs typeface="Calibri Light" panose="020F0302020204030204" pitchFamily="34" charset="0"/>
-            </a:endParaRPr>
           </a:p>
           <a:p>
             <a:pPr marL="285750" indent="-285750">
@@ -12259,11 +12018,6 @@
               </a:rPr>
               <a:t> probabilities (weights that sum to 1)</a:t>
             </a:r>
-            <a:endParaRPr lang="en-US" altLang="ja-JP" sz="1600" dirty="0">
-              <a:latin typeface="Calibri Light" panose="020F0302020204030204" pitchFamily="34" charset="0"/>
-              <a:cs typeface="Calibri Light" panose="020F0302020204030204" pitchFamily="34" charset="0"/>
-              <a:sym typeface="Wingdings" panose="05000000000000000000" pitchFamily="2" charset="2"/>
-            </a:endParaRPr>
           </a:p>
           <a:p>
             <a:pPr marL="285750" indent="-285750">
@@ -12397,13 +12151,6 @@
               </a:rPr>
               <a:t>(3) Weighted sum:</a:t>
             </a:r>
-            <a:endParaRPr lang="en-US" altLang="ja-JP" sz="1600" b="1" dirty="0">
-              <a:solidFill>
-                <a:schemeClr val="accent6"/>
-              </a:solidFill>
-              <a:latin typeface="Calibri Light" panose="020F0302020204030204" pitchFamily="34" charset="0"/>
-              <a:cs typeface="Calibri Light" panose="020F0302020204030204" pitchFamily="34" charset="0"/>
-            </a:endParaRPr>
           </a:p>
           <a:p>
             <a:pPr marL="285750" indent="-285750">
@@ -12555,7 +12302,7 @@
           <p:nvPr/>
         </p:nvPicPr>
         <p:blipFill>
-          <a:blip r:embed="rId1">
+          <a:blip r:embed="rId3">
             <a:extLst>
               <a:ext uri="{28A0092B-C50C-407E-A947-70E740481C1C}">
                 <a14:useLocalDpi xmlns:a14="http://schemas.microsoft.com/office/drawing/2010/main" val="0"/>
@@ -12621,6 +12368,125 @@
               </a:rPr>
               <a:t>Use multiple attentions to reduce the load on one attention to find all significant words.</a:t>
             </a:r>
+          </a:p>
+          <a:p>
+            <a:pPr marL="285750" indent="-285750">
+              <a:buFont typeface="Arial" panose="020B0604020202090204" pitchFamily="34" charset="0"/>
+              <a:buChar char="•"/>
+            </a:pPr>
+            <a:r>
+              <a:rPr lang="en-US" altLang="ja-JP" sz="1400" dirty="0">
+                <a:latin typeface="Calibri Light" panose="020F0302020204030204" pitchFamily="34" charset="0"/>
+                <a:ea typeface="Calibri Light" panose="020F0302020204030204" pitchFamily="34" charset="0"/>
+                <a:cs typeface="Calibri Light" panose="020F0302020204030204" pitchFamily="34" charset="0"/>
+              </a:rPr>
+              <a:t>Increase the chances of funding relevant words easily.</a:t>
+            </a:r>
+          </a:p>
+          <a:p>
+            <a:pPr marL="285750" indent="-285750">
+              <a:buFont typeface="Arial" panose="020B0604020202090204" pitchFamily="34" charset="0"/>
+              <a:buChar char="•"/>
+            </a:pPr>
+            <a:r>
+              <a:rPr kumimoji="1" lang="en-US" altLang="ja-JP" sz="1400" dirty="0">
+                <a:latin typeface="Calibri Light" panose="020F0302020204030204" pitchFamily="34" charset="0"/>
+                <a:ea typeface="Calibri Light" panose="020F0302020204030204" pitchFamily="34" charset="0"/>
+                <a:cs typeface="Calibri Light" panose="020F0302020204030204" pitchFamily="34" charset="0"/>
+              </a:rPr>
+              <a:t>Each attention block is trained </a:t>
+            </a:r>
+            <a:r>
+              <a:rPr lang="en-US" altLang="ja-JP" sz="1400" dirty="0">
+                <a:latin typeface="Calibri Light" panose="020F0302020204030204" pitchFamily="34" charset="0"/>
+                <a:ea typeface="Calibri Light" panose="020F0302020204030204" pitchFamily="34" charset="0"/>
+                <a:cs typeface="Calibri Light" panose="020F0302020204030204" pitchFamily="34" charset="0"/>
+              </a:rPr>
+              <a:t>in parallel and independent of one another.</a:t>
+            </a:r>
+            <a:endParaRPr kumimoji="1" lang="ja-JP" altLang="en-US" sz="1400" dirty="0">
+              <a:latin typeface="Calibri Light" panose="020F0302020204030204" pitchFamily="34" charset="0"/>
+              <a:cs typeface="Calibri Light" panose="020F0302020204030204" pitchFamily="34" charset="0"/>
+            </a:endParaRPr>
+          </a:p>
+        </p:txBody>
+      </p:sp>
+      <p:sp>
+        <p:nvSpPr>
+          <p:cNvPr id="4" name="TextBox 3"/>
+          <p:cNvSpPr txBox="1"/>
+          <p:nvPr/>
+        </p:nvSpPr>
+        <p:spPr>
+          <a:xfrm>
+            <a:off x="153094" y="2776150"/>
+            <a:ext cx="5942905" cy="1815882"/>
+          </a:xfrm>
+          <a:prstGeom prst="rect">
+            <a:avLst/>
+          </a:prstGeom>
+          <a:noFill/>
+        </p:spPr>
+        <p:txBody>
+          <a:bodyPr wrap="square" rtlCol="0">
+            <a:spAutoFit/>
+          </a:bodyPr>
+          <a:lstStyle/>
+          <a:p>
+            <a:r>
+              <a:rPr kumimoji="1" lang="en-US" altLang="ja-JP" sz="1400" dirty="0">
+                <a:latin typeface="Calibri Light" panose="020F0302020204030204" pitchFamily="34" charset="0"/>
+                <a:ea typeface="Calibri Light" panose="020F0302020204030204" pitchFamily="34" charset="0"/>
+                <a:cs typeface="Calibri Light" panose="020F0302020204030204" pitchFamily="34" charset="0"/>
+              </a:rPr>
+              <a:t>E.g.</a:t>
+            </a:r>
+          </a:p>
+          <a:p>
+            <a:pPr marL="285750" indent="-285750">
+              <a:buFont typeface="Arial" panose="020B0604020202090204" pitchFamily="34" charset="0"/>
+              <a:buChar char="•"/>
+            </a:pPr>
+            <a:r>
+              <a:rPr kumimoji="1" lang="en-US" altLang="ja-JP" sz="1400" dirty="0" err="1">
+                <a:latin typeface="Calibri Light" panose="020F0302020204030204" pitchFamily="34" charset="0"/>
+                <a:ea typeface="Calibri Light" panose="020F0302020204030204" pitchFamily="34" charset="0"/>
+                <a:cs typeface="Calibri Light" panose="020F0302020204030204" pitchFamily="34" charset="0"/>
+              </a:rPr>
+              <a:t>d_model</a:t>
+            </a:r>
+            <a:r>
+              <a:rPr kumimoji="1" lang="en-US" altLang="ja-JP" sz="1400" dirty="0">
+                <a:latin typeface="Calibri Light" panose="020F0302020204030204" pitchFamily="34" charset="0"/>
+                <a:ea typeface="Calibri Light" panose="020F0302020204030204" pitchFamily="34" charset="0"/>
+                <a:cs typeface="Calibri Light" panose="020F0302020204030204" pitchFamily="34" charset="0"/>
+              </a:rPr>
+              <a:t> = 512 (dim of input embeddings)</a:t>
+            </a:r>
+          </a:p>
+          <a:p>
+            <a:pPr marL="285750" indent="-285750">
+              <a:buFont typeface="Arial" panose="020B0604020202090204" pitchFamily="34" charset="0"/>
+              <a:buChar char="•"/>
+            </a:pPr>
+            <a:r>
+              <a:rPr kumimoji="1" lang="en-US" altLang="ja-JP" sz="1400" dirty="0" err="1">
+                <a:latin typeface="Calibri Light" panose="020F0302020204030204" pitchFamily="34" charset="0"/>
+                <a:ea typeface="Calibri Light" panose="020F0302020204030204" pitchFamily="34" charset="0"/>
+                <a:cs typeface="Calibri Light" panose="020F0302020204030204" pitchFamily="34" charset="0"/>
+              </a:rPr>
+              <a:t>num_heads</a:t>
+            </a:r>
+            <a:r>
+              <a:rPr kumimoji="1" lang="en-US" altLang="ja-JP" sz="1400" dirty="0">
+                <a:latin typeface="Calibri Light" panose="020F0302020204030204" pitchFamily="34" charset="0"/>
+                <a:ea typeface="Calibri Light" panose="020F0302020204030204" pitchFamily="34" charset="0"/>
+                <a:cs typeface="Calibri Light" panose="020F0302020204030204" pitchFamily="34" charset="0"/>
+              </a:rPr>
+              <a:t> = 8</a:t>
+            </a:r>
+          </a:p>
+          <a:p>
             <a:endParaRPr kumimoji="1" lang="en-US" altLang="ja-JP" sz="1400" dirty="0">
               <a:latin typeface="Calibri Light" panose="020F0302020204030204" pitchFamily="34" charset="0"/>
               <a:ea typeface="Calibri Light" panose="020F0302020204030204" pitchFamily="34" charset="0"/>
@@ -12629,97 +12495,42 @@
           </a:p>
           <a:p>
             <a:pPr marL="285750" indent="-285750">
-              <a:buFont typeface="Arial" panose="020B0604020202090204" pitchFamily="34" charset="0"/>
-              <a:buChar char="•"/>
+              <a:buFont typeface="Wingdings" panose="05000000000000000000" pitchFamily="2" charset="2"/>
+              <a:buChar char="à"/>
             </a:pPr>
             <a:r>
-              <a:rPr lang="en-US" altLang="ja-JP" sz="1400" dirty="0">
-                <a:latin typeface="Calibri Light" panose="020F0302020204030204" pitchFamily="34" charset="0"/>
-                <a:ea typeface="Calibri Light" panose="020F0302020204030204" pitchFamily="34" charset="0"/>
-                <a:cs typeface="Calibri Light" panose="020F0302020204030204" pitchFamily="34" charset="0"/>
-              </a:rPr>
-              <a:t>Increase the chances of funding relevant words easily.</a:t>
-            </a:r>
-            <a:endParaRPr lang="en-US" altLang="ja-JP" sz="1400" dirty="0">
-              <a:latin typeface="Calibri Light" panose="020F0302020204030204" pitchFamily="34" charset="0"/>
-              <a:ea typeface="Calibri Light" panose="020F0302020204030204" pitchFamily="34" charset="0"/>
-              <a:cs typeface="Calibri Light" panose="020F0302020204030204" pitchFamily="34" charset="0"/>
-            </a:endParaRPr>
-          </a:p>
-          <a:p>
-            <a:pPr marL="285750" indent="-285750">
-              <a:buFont typeface="Arial" panose="020B0604020202090204" pitchFamily="34" charset="0"/>
-              <a:buChar char="•"/>
-            </a:pPr>
-            <a:r>
               <a:rPr kumimoji="1" lang="en-US" altLang="ja-JP" sz="1400" dirty="0">
                 <a:latin typeface="Calibri Light" panose="020F0302020204030204" pitchFamily="34" charset="0"/>
                 <a:ea typeface="Calibri Light" panose="020F0302020204030204" pitchFamily="34" charset="0"/>
                 <a:cs typeface="Calibri Light" panose="020F0302020204030204" pitchFamily="34" charset="0"/>
-              </a:rPr>
-              <a:t>Each attention block is trained </a:t>
-            </a:r>
-            <a:r>
-              <a:rPr lang="en-US" altLang="ja-JP" sz="1400" dirty="0">
-                <a:latin typeface="Calibri Light" panose="020F0302020204030204" pitchFamily="34" charset="0"/>
-                <a:ea typeface="Calibri Light" panose="020F0302020204030204" pitchFamily="34" charset="0"/>
-                <a:cs typeface="Calibri Light" panose="020F0302020204030204" pitchFamily="34" charset="0"/>
-              </a:rPr>
-              <a:t>in parallel and independent of one another.</a:t>
-            </a:r>
-            <a:endParaRPr kumimoji="1" lang="ja-JP" altLang="en-US" sz="1400" dirty="0">
-              <a:latin typeface="Calibri Light" panose="020F0302020204030204" pitchFamily="34" charset="0"/>
-              <a:cs typeface="Calibri Light" panose="020F0302020204030204" pitchFamily="34" charset="0"/>
-            </a:endParaRPr>
-          </a:p>
-        </p:txBody>
-      </p:sp>
-      <p:sp>
-        <p:nvSpPr>
-          <p:cNvPr id="4" name="TextBox 3"/>
-          <p:cNvSpPr txBox="1"/>
-          <p:nvPr/>
-        </p:nvSpPr>
-        <p:spPr>
-          <a:xfrm>
-            <a:off x="153094" y="2776150"/>
-            <a:ext cx="5942905" cy="1815882"/>
-          </a:xfrm>
-          <a:prstGeom prst="rect">
-            <a:avLst/>
-          </a:prstGeom>
-          <a:noFill/>
-        </p:spPr>
-        <p:txBody>
-          <a:bodyPr wrap="square" rtlCol="0">
-            <a:spAutoFit/>
-          </a:bodyPr>
-          <a:lstStyle/>
-          <a:p>
+                <a:sym typeface="Wingdings" panose="05000000000000000000" pitchFamily="2" charset="2"/>
+              </a:rPr>
+              <a:t>Each head will operate in </a:t>
+            </a:r>
+            <a:r>
+              <a:rPr kumimoji="1" lang="en-US" altLang="ja-JP" sz="1400" dirty="0" err="1">
+                <a:latin typeface="Calibri Light" panose="020F0302020204030204" pitchFamily="34" charset="0"/>
+                <a:ea typeface="Calibri Light" panose="020F0302020204030204" pitchFamily="34" charset="0"/>
+                <a:cs typeface="Calibri Light" panose="020F0302020204030204" pitchFamily="34" charset="0"/>
+                <a:sym typeface="Wingdings" panose="05000000000000000000" pitchFamily="2" charset="2"/>
+              </a:rPr>
+              <a:t>d_k</a:t>
+            </a:r>
             <a:r>
               <a:rPr kumimoji="1" lang="en-US" altLang="ja-JP" sz="1400" dirty="0">
                 <a:latin typeface="Calibri Light" panose="020F0302020204030204" pitchFamily="34" charset="0"/>
                 <a:ea typeface="Calibri Light" panose="020F0302020204030204" pitchFamily="34" charset="0"/>
                 <a:cs typeface="Calibri Light" panose="020F0302020204030204" pitchFamily="34" charset="0"/>
-              </a:rPr>
-              <a:t>E.g.</a:t>
-            </a:r>
-            <a:endParaRPr kumimoji="1" lang="en-US" altLang="ja-JP" sz="1400" dirty="0">
-              <a:latin typeface="Calibri Light" panose="020F0302020204030204" pitchFamily="34" charset="0"/>
-              <a:ea typeface="Calibri Light" panose="020F0302020204030204" pitchFamily="34" charset="0"/>
-              <a:cs typeface="Calibri Light" panose="020F0302020204030204" pitchFamily="34" charset="0"/>
-            </a:endParaRPr>
-          </a:p>
-          <a:p>
-            <a:pPr marL="285750" indent="-285750">
-              <a:buFont typeface="Arial" panose="020B0604020202090204" pitchFamily="34" charset="0"/>
-              <a:buChar char="•"/>
-            </a:pPr>
+                <a:sym typeface="Wingdings" panose="05000000000000000000" pitchFamily="2" charset="2"/>
+              </a:rPr>
+              <a:t> = </a:t>
+            </a:r>
             <a:r>
               <a:rPr kumimoji="1" lang="en-US" altLang="ja-JP" sz="1400" dirty="0" err="1">
                 <a:latin typeface="Calibri Light" panose="020F0302020204030204" pitchFamily="34" charset="0"/>
                 <a:ea typeface="Calibri Light" panose="020F0302020204030204" pitchFamily="34" charset="0"/>
                 <a:cs typeface="Calibri Light" panose="020F0302020204030204" pitchFamily="34" charset="0"/>
+                <a:sym typeface="Wingdings" panose="05000000000000000000" pitchFamily="2" charset="2"/>
               </a:rPr>
               <a:t>d_model</a:t>
             </a:r>
@@ -12728,25 +12539,16 @@
                 <a:latin typeface="Calibri Light" panose="020F0302020204030204" pitchFamily="34" charset="0"/>
                 <a:ea typeface="Calibri Light" panose="020F0302020204030204" pitchFamily="34" charset="0"/>
                 <a:cs typeface="Calibri Light" panose="020F0302020204030204" pitchFamily="34" charset="0"/>
-              </a:rPr>
-              <a:t> = 512 (dim of input embeddings)</a:t>
-            </a:r>
-            <a:endParaRPr kumimoji="1" lang="en-US" altLang="ja-JP" sz="1400" dirty="0">
-              <a:latin typeface="Calibri Light" panose="020F0302020204030204" pitchFamily="34" charset="0"/>
-              <a:ea typeface="Calibri Light" panose="020F0302020204030204" pitchFamily="34" charset="0"/>
-              <a:cs typeface="Calibri Light" panose="020F0302020204030204" pitchFamily="34" charset="0"/>
-            </a:endParaRPr>
-          </a:p>
-          <a:p>
-            <a:pPr marL="285750" indent="-285750">
-              <a:buFont typeface="Arial" panose="020B0604020202090204" pitchFamily="34" charset="0"/>
-              <a:buChar char="•"/>
-            </a:pPr>
+                <a:sym typeface="Wingdings" panose="05000000000000000000" pitchFamily="2" charset="2"/>
+              </a:rPr>
+              <a:t> / </a:t>
+            </a:r>
             <a:r>
               <a:rPr kumimoji="1" lang="en-US" altLang="ja-JP" sz="1400" dirty="0" err="1">
                 <a:latin typeface="Calibri Light" panose="020F0302020204030204" pitchFamily="34" charset="0"/>
                 <a:ea typeface="Calibri Light" panose="020F0302020204030204" pitchFamily="34" charset="0"/>
                 <a:cs typeface="Calibri Light" panose="020F0302020204030204" pitchFamily="34" charset="0"/>
+                <a:sym typeface="Wingdings" panose="05000000000000000000" pitchFamily="2" charset="2"/>
               </a:rPr>
               <a:t>num_heads</a:t>
             </a:r>
@@ -12755,21 +12557,10 @@
                 <a:latin typeface="Calibri Light" panose="020F0302020204030204" pitchFamily="34" charset="0"/>
                 <a:ea typeface="Calibri Light" panose="020F0302020204030204" pitchFamily="34" charset="0"/>
                 <a:cs typeface="Calibri Light" panose="020F0302020204030204" pitchFamily="34" charset="0"/>
-              </a:rPr>
-              <a:t> = 8</a:t>
-            </a:r>
-            <a:endParaRPr kumimoji="1" lang="en-US" altLang="ja-JP" sz="1400" dirty="0">
-              <a:latin typeface="Calibri Light" panose="020F0302020204030204" pitchFamily="34" charset="0"/>
-              <a:ea typeface="Calibri Light" panose="020F0302020204030204" pitchFamily="34" charset="0"/>
-              <a:cs typeface="Calibri Light" panose="020F0302020204030204" pitchFamily="34" charset="0"/>
-            </a:endParaRPr>
-          </a:p>
-          <a:p>
-            <a:endParaRPr kumimoji="1" lang="en-US" altLang="ja-JP" sz="1400" dirty="0">
-              <a:latin typeface="Calibri Light" panose="020F0302020204030204" pitchFamily="34" charset="0"/>
-              <a:ea typeface="Calibri Light" panose="020F0302020204030204" pitchFamily="34" charset="0"/>
-              <a:cs typeface="Calibri Light" panose="020F0302020204030204" pitchFamily="34" charset="0"/>
-            </a:endParaRPr>
+                <a:sym typeface="Wingdings" panose="05000000000000000000" pitchFamily="2" charset="2"/>
+              </a:rPr>
+              <a:t> = 64</a:t>
+            </a:r>
           </a:p>
           <a:p>
             <a:pPr marL="285750" indent="-285750">
@@ -12777,95 +12568,14 @@
               <a:buChar char="à"/>
             </a:pPr>
             <a:r>
-              <a:rPr kumimoji="1" lang="en-US" altLang="ja-JP" sz="1400" dirty="0">
+              <a:rPr lang="en-US" altLang="ja-JP" sz="1400" dirty="0">
                 <a:latin typeface="Calibri Light" panose="020F0302020204030204" pitchFamily="34" charset="0"/>
                 <a:ea typeface="Calibri Light" panose="020F0302020204030204" pitchFamily="34" charset="0"/>
                 <a:cs typeface="Calibri Light" panose="020F0302020204030204" pitchFamily="34" charset="0"/>
                 <a:sym typeface="Wingdings" panose="05000000000000000000" pitchFamily="2" charset="2"/>
               </a:rPr>
-              <a:t>Each head will operate in </a:t>
-            </a:r>
-            <a:r>
-              <a:rPr kumimoji="1" lang="en-US" altLang="ja-JP" sz="1400" dirty="0" err="1">
-                <a:latin typeface="Calibri Light" panose="020F0302020204030204" pitchFamily="34" charset="0"/>
-                <a:ea typeface="Calibri Light" panose="020F0302020204030204" pitchFamily="34" charset="0"/>
-                <a:cs typeface="Calibri Light" panose="020F0302020204030204" pitchFamily="34" charset="0"/>
-                <a:sym typeface="Wingdings" panose="05000000000000000000" pitchFamily="2" charset="2"/>
-              </a:rPr>
-              <a:t>d_k</a:t>
-            </a:r>
-            <a:r>
-              <a:rPr kumimoji="1" lang="en-US" altLang="ja-JP" sz="1400" dirty="0">
-                <a:latin typeface="Calibri Light" panose="020F0302020204030204" pitchFamily="34" charset="0"/>
-                <a:ea typeface="Calibri Light" panose="020F0302020204030204" pitchFamily="34" charset="0"/>
-                <a:cs typeface="Calibri Light" panose="020F0302020204030204" pitchFamily="34" charset="0"/>
-                <a:sym typeface="Wingdings" panose="05000000000000000000" pitchFamily="2" charset="2"/>
-              </a:rPr>
-              <a:t> = </a:t>
-            </a:r>
-            <a:r>
-              <a:rPr kumimoji="1" lang="en-US" altLang="ja-JP" sz="1400" dirty="0" err="1">
-                <a:latin typeface="Calibri Light" panose="020F0302020204030204" pitchFamily="34" charset="0"/>
-                <a:ea typeface="Calibri Light" panose="020F0302020204030204" pitchFamily="34" charset="0"/>
-                <a:cs typeface="Calibri Light" panose="020F0302020204030204" pitchFamily="34" charset="0"/>
-                <a:sym typeface="Wingdings" panose="05000000000000000000" pitchFamily="2" charset="2"/>
-              </a:rPr>
-              <a:t>d_model</a:t>
-            </a:r>
-            <a:r>
-              <a:rPr kumimoji="1" lang="en-US" altLang="ja-JP" sz="1400" dirty="0">
-                <a:latin typeface="Calibri Light" panose="020F0302020204030204" pitchFamily="34" charset="0"/>
-                <a:ea typeface="Calibri Light" panose="020F0302020204030204" pitchFamily="34" charset="0"/>
-                <a:cs typeface="Calibri Light" panose="020F0302020204030204" pitchFamily="34" charset="0"/>
-                <a:sym typeface="Wingdings" panose="05000000000000000000" pitchFamily="2" charset="2"/>
-              </a:rPr>
-              <a:t> / </a:t>
-            </a:r>
-            <a:r>
-              <a:rPr kumimoji="1" lang="en-US" altLang="ja-JP" sz="1400" dirty="0" err="1">
-                <a:latin typeface="Calibri Light" panose="020F0302020204030204" pitchFamily="34" charset="0"/>
-                <a:ea typeface="Calibri Light" panose="020F0302020204030204" pitchFamily="34" charset="0"/>
-                <a:cs typeface="Calibri Light" panose="020F0302020204030204" pitchFamily="34" charset="0"/>
-                <a:sym typeface="Wingdings" panose="05000000000000000000" pitchFamily="2" charset="2"/>
-              </a:rPr>
-              <a:t>num_heads</a:t>
-            </a:r>
-            <a:r>
-              <a:rPr kumimoji="1" lang="en-US" altLang="ja-JP" sz="1400" dirty="0">
-                <a:latin typeface="Calibri Light" panose="020F0302020204030204" pitchFamily="34" charset="0"/>
-                <a:ea typeface="Calibri Light" panose="020F0302020204030204" pitchFamily="34" charset="0"/>
-                <a:cs typeface="Calibri Light" panose="020F0302020204030204" pitchFamily="34" charset="0"/>
-                <a:sym typeface="Wingdings" panose="05000000000000000000" pitchFamily="2" charset="2"/>
-              </a:rPr>
-              <a:t> = 64</a:t>
-            </a:r>
-            <a:endParaRPr kumimoji="1" lang="en-US" altLang="ja-JP" sz="1400" dirty="0">
-              <a:latin typeface="Calibri Light" panose="020F0302020204030204" pitchFamily="34" charset="0"/>
-              <a:ea typeface="Calibri Light" panose="020F0302020204030204" pitchFamily="34" charset="0"/>
-              <a:cs typeface="Calibri Light" panose="020F0302020204030204" pitchFamily="34" charset="0"/>
-              <a:sym typeface="Wingdings" panose="05000000000000000000" pitchFamily="2" charset="2"/>
-            </a:endParaRPr>
-          </a:p>
-          <a:p>
-            <a:pPr marL="285750" indent="-285750">
-              <a:buFont typeface="Wingdings" panose="05000000000000000000" pitchFamily="2" charset="2"/>
-              <a:buChar char="à"/>
-            </a:pPr>
-            <a:r>
-              <a:rPr lang="en-US" altLang="ja-JP" sz="1400" dirty="0">
-                <a:latin typeface="Calibri Light" panose="020F0302020204030204" pitchFamily="34" charset="0"/>
-                <a:ea typeface="Calibri Light" panose="020F0302020204030204" pitchFamily="34" charset="0"/>
-                <a:cs typeface="Calibri Light" panose="020F0302020204030204" pitchFamily="34" charset="0"/>
-                <a:sym typeface="Wingdings" panose="05000000000000000000" pitchFamily="2" charset="2"/>
-              </a:rPr>
               <a:t>For 8 heads operating in parallel, 8 different 64-dimensional outputs/token is given </a:t>
             </a:r>
-            <a:endParaRPr lang="en-US" altLang="ja-JP" sz="1400" dirty="0">
-              <a:latin typeface="Calibri Light" panose="020F0302020204030204" pitchFamily="34" charset="0"/>
-              <a:ea typeface="Calibri Light" panose="020F0302020204030204" pitchFamily="34" charset="0"/>
-              <a:cs typeface="Calibri Light" panose="020F0302020204030204" pitchFamily="34" charset="0"/>
-              <a:sym typeface="Wingdings" panose="05000000000000000000" pitchFamily="2" charset="2"/>
-            </a:endParaRPr>
           </a:p>
           <a:p>
             <a:pPr marL="285750" indent="-285750">
@@ -12991,11 +12701,6 @@
               </a:rPr>
               <a:t>1️⃣ Masked Self-Attention (first layer in decoder):</a:t>
             </a:r>
-            <a:endParaRPr kumimoji="1" lang="en-US" altLang="ja-JP" sz="1400" dirty="0">
-              <a:latin typeface="Calibri Light" panose="020F0302020204030204" pitchFamily="34" charset="0"/>
-              <a:ea typeface="Calibri Light" panose="020F0302020204030204" pitchFamily="34" charset="0"/>
-              <a:cs typeface="Calibri Light" panose="020F0302020204030204" pitchFamily="34" charset="0"/>
-            </a:endParaRPr>
           </a:p>
           <a:p>
             <a:pPr marL="285750" indent="-285750">
@@ -13042,11 +12747,6 @@
               </a:rPr>
               <a:t>.</a:t>
             </a:r>
-            <a:endParaRPr kumimoji="1" lang="en-US" altLang="ja-JP" sz="1400" dirty="0">
-              <a:latin typeface="Calibri Light" panose="020F0302020204030204" pitchFamily="34" charset="0"/>
-              <a:ea typeface="Calibri Light" panose="020F0302020204030204" pitchFamily="34" charset="0"/>
-              <a:cs typeface="Calibri Light" panose="020F0302020204030204" pitchFamily="34" charset="0"/>
-            </a:endParaRPr>
           </a:p>
           <a:p>
             <a:pPr marL="285750" indent="-285750">
@@ -13061,11 +12761,6 @@
               </a:rPr>
               <a:t>It’s masked so the model doesn’t cheat during training by peeking at tokens it hasn’t generated yet.</a:t>
             </a:r>
-            <a:endParaRPr lang="en-US" altLang="ja-JP" sz="1400" dirty="0">
-              <a:latin typeface="Calibri Light" panose="020F0302020204030204" pitchFamily="34" charset="0"/>
-              <a:ea typeface="Calibri Light" panose="020F0302020204030204" pitchFamily="34" charset="0"/>
-              <a:cs typeface="Calibri Light" panose="020F0302020204030204" pitchFamily="34" charset="0"/>
-            </a:endParaRPr>
           </a:p>
           <a:p>
             <a:pPr marL="285750" indent="-285750">
@@ -13087,11 +12782,6 @@
               </a:rPr>
               <a:t>E.g. Generating “I like dogs”</a:t>
             </a:r>
-            <a:endParaRPr lang="en-US" altLang="ja-JP" sz="1400" dirty="0">
-              <a:latin typeface="Calibri Light" panose="020F0302020204030204" pitchFamily="34" charset="0"/>
-              <a:ea typeface="Calibri Light" panose="020F0302020204030204" pitchFamily="34" charset="0"/>
-              <a:cs typeface="Calibri Light" panose="020F0302020204030204" pitchFamily="34" charset="0"/>
-            </a:endParaRPr>
           </a:p>
           <a:p>
             <a:endParaRPr kumimoji="1" lang="en-US" altLang="ja-JP" sz="1400" dirty="0">
@@ -13125,11 +12815,6 @@
               </a:rPr>
               <a:t>&gt;"]</a:t>
             </a:r>
-            <a:endParaRPr lang="en-US" altLang="ja-JP" sz="1400" dirty="0">
-              <a:latin typeface="Calibri Light" panose="020F0302020204030204" pitchFamily="34" charset="0"/>
-              <a:ea typeface="Calibri Light" panose="020F0302020204030204" pitchFamily="34" charset="0"/>
-              <a:cs typeface="Calibri Light" panose="020F0302020204030204" pitchFamily="34" charset="0"/>
-            </a:endParaRPr>
           </a:p>
           <a:p>
             <a:r>
@@ -13156,11 +12841,6 @@
               </a:rPr>
               <a:t>&gt;", "I"]</a:t>
             </a:r>
-            <a:endParaRPr lang="en-US" altLang="ja-JP" sz="1400" dirty="0">
-              <a:latin typeface="Calibri Light" panose="020F0302020204030204" pitchFamily="34" charset="0"/>
-              <a:ea typeface="Calibri Light" panose="020F0302020204030204" pitchFamily="34" charset="0"/>
-              <a:cs typeface="Calibri Light" panose="020F0302020204030204" pitchFamily="34" charset="0"/>
-            </a:endParaRPr>
           </a:p>
           <a:p>
             <a:r>
@@ -13187,11 +12867,6 @@
               </a:rPr>
               <a:t>&gt;", "I", "like"]</a:t>
             </a:r>
-            <a:endParaRPr lang="en-US" altLang="ja-JP" sz="1400" dirty="0">
-              <a:latin typeface="Calibri Light" panose="020F0302020204030204" pitchFamily="34" charset="0"/>
-              <a:ea typeface="Calibri Light" panose="020F0302020204030204" pitchFamily="34" charset="0"/>
-              <a:cs typeface="Calibri Light" panose="020F0302020204030204" pitchFamily="34" charset="0"/>
-            </a:endParaRPr>
           </a:p>
           <a:p>
             <a:endParaRPr kumimoji="1" lang="en-US" altLang="ja-JP" sz="1400" dirty="0">
@@ -13217,11 +12892,6 @@
               </a:rPr>
               <a:t>triangular causal mask</a:t>
             </a:r>
-            <a:endParaRPr lang="en-US" altLang="ja-JP" sz="1400" b="1" dirty="0">
-              <a:latin typeface="Calibri Light" panose="020F0302020204030204" pitchFamily="34" charset="0"/>
-              <a:ea typeface="Calibri Light" panose="020F0302020204030204" pitchFamily="34" charset="0"/>
-              <a:cs typeface="Calibri Light" panose="020F0302020204030204" pitchFamily="34" charset="0"/>
-            </a:endParaRPr>
           </a:p>
         </p:txBody>
       </p:sp>
@@ -13234,7 +12904,7 @@
           <p:nvPr/>
         </p:nvPicPr>
         <p:blipFill>
-          <a:blip r:embed="rId1"/>
+          <a:blip r:embed="rId2"/>
           <a:srcRect l="3285" t="10217"/>
           <a:stretch>
             <a:fillRect/>
@@ -13341,7 +13011,7 @@
           <p:nvPr/>
         </p:nvPicPr>
         <p:blipFill>
-          <a:blip r:embed="rId2"/>
+          <a:blip r:embed="rId3"/>
           <a:stretch>
             <a:fillRect/>
           </a:stretch>
@@ -13433,10 +13103,6 @@
               </a:rPr>
               <a:t>Decoder Block:</a:t>
             </a:r>
-            <a:endParaRPr lang="ja-JP" altLang="en-US" sz="1400" b="1" dirty="0">
-              <a:latin typeface="Calibri Light" panose="020F0302020204030204" pitchFamily="34" charset="0"/>
-              <a:cs typeface="Calibri Light" panose="020F0302020204030204" pitchFamily="34" charset="0"/>
-            </a:endParaRPr>
           </a:p>
           <a:p>
             <a:endParaRPr lang="ja-JP" altLang="en-US" sz="1400" dirty="0">
@@ -13452,10 +13118,6 @@
               </a:rPr>
               <a:t>Input (previous target tokens)</a:t>
             </a:r>
-            <a:endParaRPr lang="ja-JP" altLang="en-US" sz="1400" dirty="0">
-              <a:latin typeface="Calibri Light" panose="020F0302020204030204" pitchFamily="34" charset="0"/>
-              <a:cs typeface="Calibri Light" panose="020F0302020204030204" pitchFamily="34" charset="0"/>
-            </a:endParaRPr>
           </a:p>
           <a:p>
             <a:r>
@@ -13465,10 +13127,6 @@
               </a:rPr>
               <a:t>   ↓</a:t>
             </a:r>
-            <a:endParaRPr lang="ja-JP" altLang="en-US" sz="1400" dirty="0">
-              <a:latin typeface="Calibri Light" panose="020F0302020204030204" pitchFamily="34" charset="0"/>
-              <a:cs typeface="Calibri Light" panose="020F0302020204030204" pitchFamily="34" charset="0"/>
-            </a:endParaRPr>
           </a:p>
           <a:p>
             <a:r>
@@ -13481,13 +13139,6 @@
               </a:rPr>
               <a:t>Masked Self-Attention  ← only looks at past tokens</a:t>
             </a:r>
-            <a:endParaRPr lang="ja-JP" altLang="en-US" sz="1400" b="1" dirty="0">
-              <a:solidFill>
-                <a:srgbClr val="FF0000"/>
-              </a:solidFill>
-              <a:latin typeface="Calibri Light" panose="020F0302020204030204" pitchFamily="34" charset="0"/>
-              <a:cs typeface="Calibri Light" panose="020F0302020204030204" pitchFamily="34" charset="0"/>
-            </a:endParaRPr>
           </a:p>
           <a:p>
             <a:r>
@@ -13497,10 +13148,6 @@
               </a:rPr>
               <a:t>   ↓</a:t>
             </a:r>
-            <a:endParaRPr lang="ja-JP" altLang="en-US" sz="1400" dirty="0">
-              <a:latin typeface="Calibri Light" panose="020F0302020204030204" pitchFamily="34" charset="0"/>
-              <a:cs typeface="Calibri Light" panose="020F0302020204030204" pitchFamily="34" charset="0"/>
-            </a:endParaRPr>
           </a:p>
           <a:p>
             <a:r>
@@ -13510,10 +13157,6 @@
               </a:rPr>
               <a:t>Cross-Attention (encoder-decoder)  ← looks at full encoder output</a:t>
             </a:r>
-            <a:endParaRPr lang="ja-JP" altLang="en-US" sz="1400" dirty="0">
-              <a:latin typeface="Calibri Light" panose="020F0302020204030204" pitchFamily="34" charset="0"/>
-              <a:cs typeface="Calibri Light" panose="020F0302020204030204" pitchFamily="34" charset="0"/>
-            </a:endParaRPr>
           </a:p>
           <a:p>
             <a:r>
@@ -13523,10 +13166,6 @@
               </a:rPr>
               <a:t>   ↓</a:t>
             </a:r>
-            <a:endParaRPr lang="ja-JP" altLang="en-US" sz="1400" dirty="0">
-              <a:latin typeface="Calibri Light" panose="020F0302020204030204" pitchFamily="34" charset="0"/>
-              <a:cs typeface="Calibri Light" panose="020F0302020204030204" pitchFamily="34" charset="0"/>
-            </a:endParaRPr>
           </a:p>
           <a:p>
             <a:r>
@@ -13536,10 +13175,6 @@
               </a:rPr>
               <a:t>Feed-Forward Network</a:t>
             </a:r>
-            <a:endParaRPr lang="ja-JP" altLang="en-US" sz="1400" dirty="0">
-              <a:latin typeface="Calibri Light" panose="020F0302020204030204" pitchFamily="34" charset="0"/>
-              <a:cs typeface="Calibri Light" panose="020F0302020204030204" pitchFamily="34" charset="0"/>
-            </a:endParaRPr>
           </a:p>
           <a:p>
             <a:r>
@@ -13549,10 +13184,6 @@
               </a:rPr>
               <a:t>   ↓</a:t>
             </a:r>
-            <a:endParaRPr lang="ja-JP" altLang="en-US" sz="1400" dirty="0">
-              <a:latin typeface="Calibri Light" panose="020F0302020204030204" pitchFamily="34" charset="0"/>
-              <a:cs typeface="Calibri Light" panose="020F0302020204030204" pitchFamily="34" charset="0"/>
-            </a:endParaRPr>
           </a:p>
           <a:p>
             <a:r>
@@ -13562,10 +13193,6 @@
               </a:rPr>
               <a:t>Output</a:t>
             </a:r>
-            <a:endParaRPr lang="ja-JP" altLang="en-US" sz="1400" dirty="0">
-              <a:latin typeface="Calibri Light" panose="020F0302020204030204" pitchFamily="34" charset="0"/>
-              <a:cs typeface="Calibri Light" panose="020F0302020204030204" pitchFamily="34" charset="0"/>
-            </a:endParaRPr>
           </a:p>
         </p:txBody>
       </p:sp>
@@ -13635,8 +13262,8 @@
         </p:nvSpPr>
         <p:spPr>
           <a:xfrm>
-            <a:off x="419101" y="1028700"/>
-            <a:ext cx="2562224" cy="338554"/>
+            <a:off x="4" y="827370"/>
+            <a:ext cx="3024185" cy="584775"/>
           </a:xfrm>
           <a:prstGeom prst="rect">
             <a:avLst/>
@@ -13649,13 +13276,30 @@
           </a:bodyPr>
           <a:lstStyle/>
           <a:p>
+            <a:pPr algn="ctr"/>
             <a:r>
               <a:rPr kumimoji="1" lang="en-US" altLang="ja-JP" sz="1600" dirty="0">
                 <a:latin typeface="Calibri Light" panose="020F0302020204030204" pitchFamily="34" charset="0"/>
                 <a:ea typeface="Calibri Light" panose="020F0302020204030204" pitchFamily="34" charset="0"/>
                 <a:cs typeface="Calibri Light" panose="020F0302020204030204" pitchFamily="34" charset="0"/>
               </a:rPr>
-              <a:t>Tokenization &amp; Vocab (spacy)</a:t>
+              <a:t>Tokenization &amp; Vocab (</a:t>
+            </a:r>
+            <a:r>
+              <a:rPr kumimoji="1" lang="en-US" altLang="ja-JP" sz="1600" dirty="0" err="1">
+                <a:latin typeface="Calibri Light" panose="020F0302020204030204" pitchFamily="34" charset="0"/>
+                <a:ea typeface="Calibri Light" panose="020F0302020204030204" pitchFamily="34" charset="0"/>
+                <a:cs typeface="Calibri Light" panose="020F0302020204030204" pitchFamily="34" charset="0"/>
+              </a:rPr>
+              <a:t>sentencepiece</a:t>
+            </a:r>
+            <a:r>
+              <a:rPr kumimoji="1" lang="en-US" altLang="ja-JP" sz="1600" dirty="0">
+                <a:latin typeface="Calibri Light" panose="020F0302020204030204" pitchFamily="34" charset="0"/>
+                <a:ea typeface="Calibri Light" panose="020F0302020204030204" pitchFamily="34" charset="0"/>
+                <a:cs typeface="Calibri Light" panose="020F0302020204030204" pitchFamily="34" charset="0"/>
+              </a:rPr>
+              <a:t>)</a:t>
             </a:r>
             <a:endParaRPr kumimoji="1" lang="ja-JP" altLang="en-US" sz="1600" dirty="0">
               <a:latin typeface="Calibri Light" panose="020F0302020204030204" pitchFamily="34" charset="0"/>
@@ -14168,11 +13812,6 @@
               </a:rPr>
               <a:t>Refs</a:t>
             </a:r>
-            <a:endParaRPr kumimoji="1" lang="en-US" altLang="ja-JP" b="1" dirty="0">
-              <a:latin typeface="Calibri Light" panose="020F0302020204030204" pitchFamily="34" charset="0"/>
-              <a:ea typeface="Calibri Light" panose="020F0302020204030204" pitchFamily="34" charset="0"/>
-              <a:cs typeface="Calibri Light" panose="020F0302020204030204" pitchFamily="34" charset="0"/>
-            </a:endParaRPr>
           </a:p>
           <a:p>
             <a:pPr marL="342900" indent="-342900">
@@ -14184,7 +13823,7 @@
                 <a:latin typeface="Calibri Light" panose="020F0302020204030204" pitchFamily="34" charset="0"/>
                 <a:ea typeface="Calibri Light" panose="020F0302020204030204" pitchFamily="34" charset="0"/>
                 <a:cs typeface="Calibri Light" panose="020F0302020204030204" pitchFamily="34" charset="0"/>
-                <a:hlinkClick r:id="rId1"/>
+                <a:hlinkClick r:id="rId2"/>
               </a:rPr>
               <a:t>https://github.com/SamLynnEvans/Transformer</a:t>
             </a:r>
@@ -15907,6 +15546,8 @@
       </a:bgFillStyleLst>
     </a:fmtScheme>
   </a:themeElements>
+  <a:objectDefaults/>
+  <a:extraClrSchemeLst/>
   <a:extLst>
     <a:ext uri="{05A4C25C-085E-4340-85A3-A5531E510DB2}">
       <thm15:themeFamily xmlns:thm15="http://schemas.microsoft.com/office/thememl/2012/main" name="Office Theme" id="{62F939B6-93AF-4DB8-9C6B-D6C7DFDC589F}" vid="{4A3C46E8-61CC-4603-A589-7422A47A8E4A}"/>
@@ -16166,6 +15807,8 @@
       </a:bgFillStyleLst>
     </a:fmtScheme>
   </a:themeElements>
+  <a:objectDefaults/>
+  <a:extraClrSchemeLst/>
   <a:extLst>
     <a:ext uri="{05A4C25C-085E-4340-85A3-A5531E510DB2}">
       <thm15:themeFamily xmlns:thm15="http://schemas.microsoft.com/office/thememl/2012/main" name="Office Theme" id="{62F939B6-93AF-4DB8-9C6B-D6C7DFDC589F}" vid="{4A3C46E8-61CC-4603-A589-7422A47A8E4A}"/>
@@ -16425,6 +16068,8 @@
       </a:bgFillStyleLst>
     </a:fmtScheme>
   </a:themeElements>
+  <a:objectDefaults/>
+  <a:extraClrSchemeLst/>
   <a:extLst>
     <a:ext uri="{05A4C25C-085E-4340-85A3-A5531E510DB2}">
       <thm15:themeFamily xmlns:thm15="http://schemas.microsoft.com/office/thememl/2012/main" name="Office Theme" id="{62F939B6-93AF-4DB8-9C6B-D6C7DFDC589F}" vid="{4A3C46E8-61CC-4603-A589-7422A47A8E4A}"/>

</xml_diff>